<commit_message>
Updated lecture 6 PowerPoint
</commit_message>
<xml_diff>
--- a/ECE1390_Homework.pptx
+++ b/ECE1390_Homework.pptx
@@ -211,7 +211,7 @@
           <a:p>
             <a:fld id="{460182BA-D6B2-8C4C-A437-30BC8B3E8EFF}" type="datetimeFigureOut">
               <a:rPr lang="en-US" smtClean="0"/>
-              <a:t>8/7/24</a:t>
+              <a:t>9/8/24</a:t>
             </a:fld>
             <a:endParaRPr lang="en-US"/>
           </a:p>
@@ -793,7 +793,7 @@
           <a:p>
             <a:fld id="{13E9B49C-C8FD-4344-8CD3-ED4C91409D68}" type="datetimeFigureOut">
               <a:rPr lang="en-US" smtClean="0"/>
-              <a:t>8/7/24</a:t>
+              <a:t>9/8/24</a:t>
             </a:fld>
             <a:endParaRPr lang="en-US"/>
           </a:p>
@@ -991,7 +991,7 @@
           <a:p>
             <a:fld id="{13E9B49C-C8FD-4344-8CD3-ED4C91409D68}" type="datetimeFigureOut">
               <a:rPr lang="en-US" smtClean="0"/>
-              <a:t>8/7/24</a:t>
+              <a:t>9/8/24</a:t>
             </a:fld>
             <a:endParaRPr lang="en-US"/>
           </a:p>
@@ -1199,7 +1199,7 @@
           <a:p>
             <a:fld id="{13E9B49C-C8FD-4344-8CD3-ED4C91409D68}" type="datetimeFigureOut">
               <a:rPr lang="en-US" smtClean="0"/>
-              <a:t>8/7/24</a:t>
+              <a:t>9/8/24</a:t>
             </a:fld>
             <a:endParaRPr lang="en-US"/>
           </a:p>
@@ -1397,7 +1397,7 @@
           <a:p>
             <a:fld id="{13E9B49C-C8FD-4344-8CD3-ED4C91409D68}" type="datetimeFigureOut">
               <a:rPr lang="en-US" smtClean="0"/>
-              <a:t>8/7/24</a:t>
+              <a:t>9/8/24</a:t>
             </a:fld>
             <a:endParaRPr lang="en-US"/>
           </a:p>
@@ -1672,7 +1672,7 @@
           <a:p>
             <a:fld id="{13E9B49C-C8FD-4344-8CD3-ED4C91409D68}" type="datetimeFigureOut">
               <a:rPr lang="en-US" smtClean="0"/>
-              <a:t>8/7/24</a:t>
+              <a:t>9/8/24</a:t>
             </a:fld>
             <a:endParaRPr lang="en-US"/>
           </a:p>
@@ -1937,7 +1937,7 @@
           <a:p>
             <a:fld id="{13E9B49C-C8FD-4344-8CD3-ED4C91409D68}" type="datetimeFigureOut">
               <a:rPr lang="en-US" smtClean="0"/>
-              <a:t>8/7/24</a:t>
+              <a:t>9/8/24</a:t>
             </a:fld>
             <a:endParaRPr lang="en-US"/>
           </a:p>
@@ -2349,7 +2349,7 @@
           <a:p>
             <a:fld id="{13E9B49C-C8FD-4344-8CD3-ED4C91409D68}" type="datetimeFigureOut">
               <a:rPr lang="en-US" smtClean="0"/>
-              <a:t>8/7/24</a:t>
+              <a:t>9/8/24</a:t>
             </a:fld>
             <a:endParaRPr lang="en-US"/>
           </a:p>
@@ -2490,7 +2490,7 @@
           <a:p>
             <a:fld id="{13E9B49C-C8FD-4344-8CD3-ED4C91409D68}" type="datetimeFigureOut">
               <a:rPr lang="en-US" smtClean="0"/>
-              <a:t>8/7/24</a:t>
+              <a:t>9/8/24</a:t>
             </a:fld>
             <a:endParaRPr lang="en-US"/>
           </a:p>
@@ -2603,7 +2603,7 @@
           <a:p>
             <a:fld id="{13E9B49C-C8FD-4344-8CD3-ED4C91409D68}" type="datetimeFigureOut">
               <a:rPr lang="en-US" smtClean="0"/>
-              <a:t>8/7/24</a:t>
+              <a:t>9/8/24</a:t>
             </a:fld>
             <a:endParaRPr lang="en-US"/>
           </a:p>
@@ -2914,7 +2914,7 @@
           <a:p>
             <a:fld id="{13E9B49C-C8FD-4344-8CD3-ED4C91409D68}" type="datetimeFigureOut">
               <a:rPr lang="en-US" smtClean="0"/>
-              <a:t>8/7/24</a:t>
+              <a:t>9/8/24</a:t>
             </a:fld>
             <a:endParaRPr lang="en-US"/>
           </a:p>
@@ -3202,7 +3202,7 @@
           <a:p>
             <a:fld id="{13E9B49C-C8FD-4344-8CD3-ED4C91409D68}" type="datetimeFigureOut">
               <a:rPr lang="en-US" smtClean="0"/>
-              <a:t>8/7/24</a:t>
+              <a:t>9/8/24</a:t>
             </a:fld>
             <a:endParaRPr lang="en-US"/>
           </a:p>
@@ -3443,7 +3443,7 @@
           <a:p>
             <a:fld id="{13E9B49C-C8FD-4344-8CD3-ED4C91409D68}" type="datetimeFigureOut">
               <a:rPr lang="en-US" smtClean="0"/>
-              <a:t>8/7/24</a:t>
+              <a:t>9/8/24</a:t>
             </a:fld>
             <a:endParaRPr lang="en-US"/>
           </a:p>
@@ -3875,7 +3875,7 @@
           <p:nvPr>
             <p:extLst>
               <p:ext uri="{D42A27DB-BD31-4B8C-83A1-F6EECF244321}">
-                <p14:modId xmlns:p14="http://schemas.microsoft.com/office/powerpoint/2010/main" val="3792565883"/>
+                <p14:modId xmlns:p14="http://schemas.microsoft.com/office/powerpoint/2010/main" val="3161862740"/>
               </p:ext>
             </p:extLst>
           </p:nvPr>
@@ -5054,12 +5054,9 @@
                     <a:bodyPr/>
                     <a:lstStyle/>
                     <a:p>
-                      <a:r>
-                        <a:rPr lang="en-US" sz="1800" dirty="0">
-                          <a:effectLst/>
-                        </a:rPr>
-                        <a:t>White paper on project</a:t>
-                      </a:r>
+                      <a:endParaRPr lang="en-US" sz="1800" dirty="0">
+                        <a:effectLst/>
+                      </a:endParaRPr>
                     </a:p>
                   </a:txBody>
                   <a:tcPr marL="4649" marR="4649" marT="4649" marB="4649" anchor="ctr">
@@ -5404,9 +5401,15 @@
                     <a:bodyPr/>
                     <a:lstStyle/>
                     <a:p>
-                      <a:endParaRPr lang="en-US" sz="1800" dirty="0">
-                        <a:effectLst/>
-                      </a:endParaRPr>
+                      <a:r>
+                        <a:rPr lang="en-US" sz="1800" dirty="0">
+                          <a:effectLst/>
+                          <a:highlight>
+                            <a:srgbClr val="FFFF00"/>
+                          </a:highlight>
+                        </a:rPr>
+                        <a:t>White paper on project</a:t>
+                      </a:r>
                     </a:p>
                   </a:txBody>
                   <a:tcPr marL="4649" marR="4649" marT="4649" marB="4649" anchor="ctr">

</xml_diff>

<commit_message>
Made edits to lectures 5 and 6
</commit_message>
<xml_diff>
--- a/ECE1390_Homework.pptx
+++ b/ECE1390_Homework.pptx
@@ -5,24 +5,25 @@
     <p:sldMasterId id="2147483648" r:id="rId1"/>
   </p:sldMasterIdLst>
   <p:notesMasterIdLst>
-    <p:notesMasterId r:id="rId17"/>
+    <p:notesMasterId r:id="rId18"/>
   </p:notesMasterIdLst>
   <p:sldIdLst>
     <p:sldId id="262" r:id="rId2"/>
-    <p:sldId id="342" r:id="rId3"/>
-    <p:sldId id="343" r:id="rId4"/>
-    <p:sldId id="344" r:id="rId5"/>
-    <p:sldId id="345" r:id="rId6"/>
-    <p:sldId id="346" r:id="rId7"/>
-    <p:sldId id="347" r:id="rId8"/>
-    <p:sldId id="348" r:id="rId9"/>
-    <p:sldId id="349" r:id="rId10"/>
-    <p:sldId id="350" r:id="rId11"/>
-    <p:sldId id="351" r:id="rId12"/>
-    <p:sldId id="352" r:id="rId13"/>
-    <p:sldId id="353" r:id="rId14"/>
-    <p:sldId id="354" r:id="rId15"/>
-    <p:sldId id="355" r:id="rId16"/>
+    <p:sldId id="356" r:id="rId3"/>
+    <p:sldId id="342" r:id="rId4"/>
+    <p:sldId id="343" r:id="rId5"/>
+    <p:sldId id="344" r:id="rId6"/>
+    <p:sldId id="345" r:id="rId7"/>
+    <p:sldId id="346" r:id="rId8"/>
+    <p:sldId id="347" r:id="rId9"/>
+    <p:sldId id="348" r:id="rId10"/>
+    <p:sldId id="349" r:id="rId11"/>
+    <p:sldId id="350" r:id="rId12"/>
+    <p:sldId id="351" r:id="rId13"/>
+    <p:sldId id="352" r:id="rId14"/>
+    <p:sldId id="353" r:id="rId15"/>
+    <p:sldId id="354" r:id="rId16"/>
+    <p:sldId id="355" r:id="rId17"/>
   </p:sldIdLst>
   <p:sldSz cx="12192000" cy="6858000"/>
   <p:notesSz cx="6858000" cy="9144000"/>
@@ -211,7 +212,7 @@
           <a:p>
             <a:fld id="{460182BA-D6B2-8C4C-A437-30BC8B3E8EFF}" type="datetimeFigureOut">
               <a:rPr lang="en-US" smtClean="0"/>
-              <a:t>9/8/24</a:t>
+              <a:t>9/11/24</a:t>
             </a:fld>
             <a:endParaRPr lang="en-US"/>
           </a:p>
@@ -567,6 +568,114 @@
   <p:cSld>
     <p:spTree>
       <p:nvGrpSpPr>
+        <p:cNvPr id="1" name="">
+          <a:extLst>
+            <a:ext uri="{FF2B5EF4-FFF2-40B4-BE49-F238E27FC236}">
+              <a16:creationId xmlns:a16="http://schemas.microsoft.com/office/drawing/2014/main" id="{686E6A3B-E84F-F9FA-B8A0-8DE65DDC5B93}"/>
+            </a:ext>
+          </a:extLst>
+        </p:cNvPr>
+        <p:cNvGrpSpPr/>
+        <p:nvPr/>
+      </p:nvGrpSpPr>
+      <p:grpSpPr>
+        <a:xfrm>
+          <a:off x="0" y="0"/>
+          <a:ext cx="0" cy="0"/>
+          <a:chOff x="0" y="0"/>
+          <a:chExt cx="0" cy="0"/>
+        </a:xfrm>
+      </p:grpSpPr>
+      <p:sp>
+        <p:nvSpPr>
+          <p:cNvPr id="2" name="Slide Image Placeholder 1">
+            <a:extLst>
+              <a:ext uri="{FF2B5EF4-FFF2-40B4-BE49-F238E27FC236}">
+                <a16:creationId xmlns:a16="http://schemas.microsoft.com/office/drawing/2014/main" id="{03EDDC21-84F7-1A51-D7E4-E5A0C8A0F213}"/>
+              </a:ext>
+            </a:extLst>
+          </p:cNvPr>
+          <p:cNvSpPr>
+            <a:spLocks noGrp="1" noRot="1" noChangeAspect="1"/>
+          </p:cNvSpPr>
+          <p:nvPr>
+            <p:ph type="sldImg"/>
+          </p:nvPr>
+        </p:nvSpPr>
+        <p:spPr/>
+      </p:sp>
+      <p:sp>
+        <p:nvSpPr>
+          <p:cNvPr id="3" name="Notes Placeholder 2">
+            <a:extLst>
+              <a:ext uri="{FF2B5EF4-FFF2-40B4-BE49-F238E27FC236}">
+                <a16:creationId xmlns:a16="http://schemas.microsoft.com/office/drawing/2014/main" id="{9FE8B921-168A-4294-543A-D9B2AAC56B25}"/>
+              </a:ext>
+            </a:extLst>
+          </p:cNvPr>
+          <p:cNvSpPr>
+            <a:spLocks noGrp="1"/>
+          </p:cNvSpPr>
+          <p:nvPr>
+            <p:ph type="body" idx="1"/>
+          </p:nvPr>
+        </p:nvSpPr>
+        <p:spPr/>
+        <p:txBody>
+          <a:bodyPr/>
+          <a:lstStyle/>
+          <a:p>
+            <a:endParaRPr lang="en-US" dirty="0"/>
+          </a:p>
+        </p:txBody>
+      </p:sp>
+      <p:sp>
+        <p:nvSpPr>
+          <p:cNvPr id="4" name="Slide Number Placeholder 3">
+            <a:extLst>
+              <a:ext uri="{FF2B5EF4-FFF2-40B4-BE49-F238E27FC236}">
+                <a16:creationId xmlns:a16="http://schemas.microsoft.com/office/drawing/2014/main" id="{BF627ACC-8AE0-B624-41CA-D87FE5BA0D58}"/>
+              </a:ext>
+            </a:extLst>
+          </p:cNvPr>
+          <p:cNvSpPr>
+            <a:spLocks noGrp="1"/>
+          </p:cNvSpPr>
+          <p:nvPr>
+            <p:ph type="sldNum" sz="quarter" idx="5"/>
+          </p:nvPr>
+        </p:nvSpPr>
+        <p:spPr/>
+        <p:txBody>
+          <a:bodyPr/>
+          <a:lstStyle/>
+          <a:p>
+            <a:fld id="{94B5C116-8FE2-EF4A-B3C0-8D058563571F}" type="slidenum">
+              <a:rPr lang="en-US" smtClean="0"/>
+              <a:t>2</a:t>
+            </a:fld>
+            <a:endParaRPr lang="en-US"/>
+          </a:p>
+        </p:txBody>
+      </p:sp>
+    </p:spTree>
+    <p:extLst>
+      <p:ext uri="{BB962C8B-B14F-4D97-AF65-F5344CB8AC3E}">
+        <p14:creationId xmlns:p14="http://schemas.microsoft.com/office/powerpoint/2010/main" val="3166026922"/>
+      </p:ext>
+    </p:extLst>
+  </p:cSld>
+  <p:clrMapOvr>
+    <a:masterClrMapping/>
+  </p:clrMapOvr>
+</p:notes>
+</file>
+
+<file path=ppt/notesSlides/notesSlide3.xml><?xml version="1.0" encoding="utf-8"?>
+<p:notes xmlns:a="http://schemas.openxmlformats.org/drawingml/2006/main" xmlns:r="http://schemas.openxmlformats.org/officeDocument/2006/relationships" xmlns:p="http://schemas.openxmlformats.org/presentationml/2006/main">
+  <p:cSld>
+    <p:spTree>
+      <p:nvGrpSpPr>
         <p:cNvPr id="1" name=""/>
         <p:cNvGrpSpPr/>
         <p:nvPr/>
@@ -627,7 +736,7 @@
           <a:p>
             <a:fld id="{94B5C116-8FE2-EF4A-B3C0-8D058563571F}" type="slidenum">
               <a:rPr lang="en-US" smtClean="0"/>
-              <a:t>2</a:t>
+              <a:t>3</a:t>
             </a:fld>
             <a:endParaRPr lang="en-US"/>
           </a:p>
@@ -793,7 +902,7 @@
           <a:p>
             <a:fld id="{13E9B49C-C8FD-4344-8CD3-ED4C91409D68}" type="datetimeFigureOut">
               <a:rPr lang="en-US" smtClean="0"/>
-              <a:t>9/8/24</a:t>
+              <a:t>9/11/24</a:t>
             </a:fld>
             <a:endParaRPr lang="en-US"/>
           </a:p>
@@ -991,7 +1100,7 @@
           <a:p>
             <a:fld id="{13E9B49C-C8FD-4344-8CD3-ED4C91409D68}" type="datetimeFigureOut">
               <a:rPr lang="en-US" smtClean="0"/>
-              <a:t>9/8/24</a:t>
+              <a:t>9/11/24</a:t>
             </a:fld>
             <a:endParaRPr lang="en-US"/>
           </a:p>
@@ -1199,7 +1308,7 @@
           <a:p>
             <a:fld id="{13E9B49C-C8FD-4344-8CD3-ED4C91409D68}" type="datetimeFigureOut">
               <a:rPr lang="en-US" smtClean="0"/>
-              <a:t>9/8/24</a:t>
+              <a:t>9/11/24</a:t>
             </a:fld>
             <a:endParaRPr lang="en-US"/>
           </a:p>
@@ -1397,7 +1506,7 @@
           <a:p>
             <a:fld id="{13E9B49C-C8FD-4344-8CD3-ED4C91409D68}" type="datetimeFigureOut">
               <a:rPr lang="en-US" smtClean="0"/>
-              <a:t>9/8/24</a:t>
+              <a:t>9/11/24</a:t>
             </a:fld>
             <a:endParaRPr lang="en-US"/>
           </a:p>
@@ -1672,7 +1781,7 @@
           <a:p>
             <a:fld id="{13E9B49C-C8FD-4344-8CD3-ED4C91409D68}" type="datetimeFigureOut">
               <a:rPr lang="en-US" smtClean="0"/>
-              <a:t>9/8/24</a:t>
+              <a:t>9/11/24</a:t>
             </a:fld>
             <a:endParaRPr lang="en-US"/>
           </a:p>
@@ -1937,7 +2046,7 @@
           <a:p>
             <a:fld id="{13E9B49C-C8FD-4344-8CD3-ED4C91409D68}" type="datetimeFigureOut">
               <a:rPr lang="en-US" smtClean="0"/>
-              <a:t>9/8/24</a:t>
+              <a:t>9/11/24</a:t>
             </a:fld>
             <a:endParaRPr lang="en-US"/>
           </a:p>
@@ -2349,7 +2458,7 @@
           <a:p>
             <a:fld id="{13E9B49C-C8FD-4344-8CD3-ED4C91409D68}" type="datetimeFigureOut">
               <a:rPr lang="en-US" smtClean="0"/>
-              <a:t>9/8/24</a:t>
+              <a:t>9/11/24</a:t>
             </a:fld>
             <a:endParaRPr lang="en-US"/>
           </a:p>
@@ -2490,7 +2599,7 @@
           <a:p>
             <a:fld id="{13E9B49C-C8FD-4344-8CD3-ED4C91409D68}" type="datetimeFigureOut">
               <a:rPr lang="en-US" smtClean="0"/>
-              <a:t>9/8/24</a:t>
+              <a:t>9/11/24</a:t>
             </a:fld>
             <a:endParaRPr lang="en-US"/>
           </a:p>
@@ -2603,7 +2712,7 @@
           <a:p>
             <a:fld id="{13E9B49C-C8FD-4344-8CD3-ED4C91409D68}" type="datetimeFigureOut">
               <a:rPr lang="en-US" smtClean="0"/>
-              <a:t>9/8/24</a:t>
+              <a:t>9/11/24</a:t>
             </a:fld>
             <a:endParaRPr lang="en-US"/>
           </a:p>
@@ -2914,7 +3023,7 @@
           <a:p>
             <a:fld id="{13E9B49C-C8FD-4344-8CD3-ED4C91409D68}" type="datetimeFigureOut">
               <a:rPr lang="en-US" smtClean="0"/>
-              <a:t>9/8/24</a:t>
+              <a:t>9/11/24</a:t>
             </a:fld>
             <a:endParaRPr lang="en-US"/>
           </a:p>
@@ -3202,7 +3311,7 @@
           <a:p>
             <a:fld id="{13E9B49C-C8FD-4344-8CD3-ED4C91409D68}" type="datetimeFigureOut">
               <a:rPr lang="en-US" smtClean="0"/>
-              <a:t>9/8/24</a:t>
+              <a:t>9/11/24</a:t>
             </a:fld>
             <a:endParaRPr lang="en-US"/>
           </a:p>
@@ -3443,7 +3552,7 @@
           <a:p>
             <a:fld id="{13E9B49C-C8FD-4344-8CD3-ED4C91409D68}" type="datetimeFigureOut">
               <a:rPr lang="en-US" smtClean="0"/>
-              <a:t>9/8/24</a:t>
+              <a:t>9/11/24</a:t>
             </a:fld>
             <a:endParaRPr lang="en-US"/>
           </a:p>
@@ -6772,7 +6881,7 @@
           <a:p>
             <a:r>
               <a:rPr lang="en-US" dirty="0"/>
-              <a:t>HW7. Camera Calibration</a:t>
+              <a:t>HW6. HDR and Panoramas</a:t>
             </a:r>
           </a:p>
         </p:txBody>
@@ -6805,7 +6914,7 @@
     </p:spTree>
     <p:extLst>
       <p:ext uri="{BB962C8B-B14F-4D97-AF65-F5344CB8AC3E}">
-        <p14:creationId xmlns:p14="http://schemas.microsoft.com/office/powerpoint/2010/main" val="3377679550"/>
+        <p14:creationId xmlns:p14="http://schemas.microsoft.com/office/powerpoint/2010/main" val="1527702628"/>
       </p:ext>
     </p:extLst>
   </p:cSld>
@@ -6855,7 +6964,7 @@
           <a:p>
             <a:r>
               <a:rPr lang="en-US" dirty="0"/>
-              <a:t>HW8. Depth estimation</a:t>
+              <a:t>HW7. Camera Calibration</a:t>
             </a:r>
           </a:p>
         </p:txBody>
@@ -6888,7 +6997,7 @@
     </p:spTree>
     <p:extLst>
       <p:ext uri="{BB962C8B-B14F-4D97-AF65-F5344CB8AC3E}">
-        <p14:creationId xmlns:p14="http://schemas.microsoft.com/office/powerpoint/2010/main" val="2773132672"/>
+        <p14:creationId xmlns:p14="http://schemas.microsoft.com/office/powerpoint/2010/main" val="3377679550"/>
       </p:ext>
     </p:extLst>
   </p:cSld>
@@ -6938,7 +7047,7 @@
           <a:p>
             <a:r>
               <a:rPr lang="en-US" dirty="0"/>
-              <a:t>HW9. Classifiers</a:t>
+              <a:t>HW8. Depth estimation</a:t>
             </a:r>
           </a:p>
         </p:txBody>
@@ -6971,7 +7080,7 @@
     </p:spTree>
     <p:extLst>
       <p:ext uri="{BB962C8B-B14F-4D97-AF65-F5344CB8AC3E}">
-        <p14:creationId xmlns:p14="http://schemas.microsoft.com/office/powerpoint/2010/main" val="1535851401"/>
+        <p14:creationId xmlns:p14="http://schemas.microsoft.com/office/powerpoint/2010/main" val="2773132672"/>
       </p:ext>
     </p:extLst>
   </p:cSld>
@@ -7021,7 +7130,7 @@
           <a:p>
             <a:r>
               <a:rPr lang="en-US" dirty="0"/>
-              <a:t>HW10. Custom detectors</a:t>
+              <a:t>HW9. Classifiers</a:t>
             </a:r>
           </a:p>
         </p:txBody>
@@ -7054,7 +7163,7 @@
     </p:spTree>
     <p:extLst>
       <p:ext uri="{BB962C8B-B14F-4D97-AF65-F5344CB8AC3E}">
-        <p14:creationId xmlns:p14="http://schemas.microsoft.com/office/powerpoint/2010/main" val="1653616656"/>
+        <p14:creationId xmlns:p14="http://schemas.microsoft.com/office/powerpoint/2010/main" val="1535851401"/>
       </p:ext>
     </p:extLst>
   </p:cSld>
@@ -7104,7 +7213,7 @@
           <a:p>
             <a:r>
               <a:rPr lang="en-US" dirty="0"/>
-              <a:t>HW11. OCR</a:t>
+              <a:t>HW10. Custom detectors</a:t>
             </a:r>
           </a:p>
         </p:txBody>
@@ -7137,7 +7246,7 @@
     </p:spTree>
     <p:extLst>
       <p:ext uri="{BB962C8B-B14F-4D97-AF65-F5344CB8AC3E}">
-        <p14:creationId xmlns:p14="http://schemas.microsoft.com/office/powerpoint/2010/main" val="1369407845"/>
+        <p14:creationId xmlns:p14="http://schemas.microsoft.com/office/powerpoint/2010/main" val="1653616656"/>
       </p:ext>
     </p:extLst>
   </p:cSld>
@@ -7187,7 +7296,7 @@
           <a:p>
             <a:r>
               <a:rPr lang="en-US" dirty="0"/>
-              <a:t>HW12. OpenCV DNN models</a:t>
+              <a:t>HW11. OCR</a:t>
             </a:r>
           </a:p>
         </p:txBody>
@@ -7220,6 +7329,89 @@
     </p:spTree>
     <p:extLst>
       <p:ext uri="{BB962C8B-B14F-4D97-AF65-F5344CB8AC3E}">
+        <p14:creationId xmlns:p14="http://schemas.microsoft.com/office/powerpoint/2010/main" val="1369407845"/>
+      </p:ext>
+    </p:extLst>
+  </p:cSld>
+  <p:clrMapOvr>
+    <a:masterClrMapping/>
+  </p:clrMapOvr>
+</p:sld>
+</file>
+
+<file path=ppt/slides/slide16.xml><?xml version="1.0" encoding="utf-8"?>
+<p:sld xmlns:a="http://schemas.openxmlformats.org/drawingml/2006/main" xmlns:r="http://schemas.openxmlformats.org/officeDocument/2006/relationships" xmlns:p="http://schemas.openxmlformats.org/presentationml/2006/main">
+  <p:cSld>
+    <p:spTree>
+      <p:nvGrpSpPr>
+        <p:cNvPr id="1" name=""/>
+        <p:cNvGrpSpPr/>
+        <p:nvPr/>
+      </p:nvGrpSpPr>
+      <p:grpSpPr>
+        <a:xfrm>
+          <a:off x="0" y="0"/>
+          <a:ext cx="0" cy="0"/>
+          <a:chOff x="0" y="0"/>
+          <a:chExt cx="0" cy="0"/>
+        </a:xfrm>
+      </p:grpSpPr>
+      <p:sp>
+        <p:nvSpPr>
+          <p:cNvPr id="2" name="Title 1">
+            <a:extLst>
+              <a:ext uri="{FF2B5EF4-FFF2-40B4-BE49-F238E27FC236}">
+                <a16:creationId xmlns:a16="http://schemas.microsoft.com/office/drawing/2014/main" id="{24120F1E-3E0A-C75A-B4EB-22E7096A349C}"/>
+              </a:ext>
+            </a:extLst>
+          </p:cNvPr>
+          <p:cNvSpPr>
+            <a:spLocks noGrp="1"/>
+          </p:cNvSpPr>
+          <p:nvPr>
+            <p:ph type="title"/>
+          </p:nvPr>
+        </p:nvSpPr>
+        <p:spPr/>
+        <p:txBody>
+          <a:bodyPr/>
+          <a:lstStyle/>
+          <a:p>
+            <a:r>
+              <a:rPr lang="en-US" dirty="0"/>
+              <a:t>HW12. OpenCV DNN models</a:t>
+            </a:r>
+          </a:p>
+        </p:txBody>
+      </p:sp>
+      <p:sp>
+        <p:nvSpPr>
+          <p:cNvPr id="3" name="Content Placeholder 2">
+            <a:extLst>
+              <a:ext uri="{FF2B5EF4-FFF2-40B4-BE49-F238E27FC236}">
+                <a16:creationId xmlns:a16="http://schemas.microsoft.com/office/drawing/2014/main" id="{9F9D029D-2EB4-B7AE-F12C-E6C724512380}"/>
+              </a:ext>
+            </a:extLst>
+          </p:cNvPr>
+          <p:cNvSpPr>
+            <a:spLocks noGrp="1"/>
+          </p:cNvSpPr>
+          <p:nvPr>
+            <p:ph idx="1"/>
+          </p:nvPr>
+        </p:nvSpPr>
+        <p:spPr/>
+        <p:txBody>
+          <a:bodyPr/>
+          <a:lstStyle/>
+          <a:p>
+            <a:endParaRPr lang="en-US" dirty="0"/>
+          </a:p>
+        </p:txBody>
+      </p:sp>
+    </p:spTree>
+    <p:extLst>
+      <p:ext uri="{BB962C8B-B14F-4D97-AF65-F5344CB8AC3E}">
         <p14:creationId xmlns:p14="http://schemas.microsoft.com/office/powerpoint/2010/main" val="3031965073"/>
       </p:ext>
     </p:extLst>
@@ -7231,6 +7423,2924 @@
 </file>
 
 <file path=ppt/slides/slide2.xml><?xml version="1.0" encoding="utf-8"?>
+<p:sld xmlns:a="http://schemas.openxmlformats.org/drawingml/2006/main" xmlns:r="http://schemas.openxmlformats.org/officeDocument/2006/relationships" xmlns:p="http://schemas.openxmlformats.org/presentationml/2006/main">
+  <p:cSld>
+    <p:spTree>
+      <p:nvGrpSpPr>
+        <p:cNvPr id="1" name="">
+          <a:extLst>
+            <a:ext uri="{FF2B5EF4-FFF2-40B4-BE49-F238E27FC236}">
+              <a16:creationId xmlns:a16="http://schemas.microsoft.com/office/drawing/2014/main" id="{9822C3EE-5347-9B48-CAE0-2283443876D0}"/>
+            </a:ext>
+          </a:extLst>
+        </p:cNvPr>
+        <p:cNvGrpSpPr/>
+        <p:nvPr/>
+      </p:nvGrpSpPr>
+      <p:grpSpPr>
+        <a:xfrm>
+          <a:off x="0" y="0"/>
+          <a:ext cx="0" cy="0"/>
+          <a:chOff x="0" y="0"/>
+          <a:chExt cx="0" cy="0"/>
+        </a:xfrm>
+      </p:grpSpPr>
+      <p:graphicFrame>
+        <p:nvGraphicFramePr>
+          <p:cNvPr id="4" name="Table 3">
+            <a:extLst>
+              <a:ext uri="{FF2B5EF4-FFF2-40B4-BE49-F238E27FC236}">
+                <a16:creationId xmlns:a16="http://schemas.microsoft.com/office/drawing/2014/main" id="{334687B1-E27C-C4A3-B85E-FBB702B7CAF0}"/>
+              </a:ext>
+            </a:extLst>
+          </p:cNvPr>
+          <p:cNvGraphicFramePr>
+            <a:graphicFrameLocks noGrp="1"/>
+          </p:cNvGraphicFramePr>
+          <p:nvPr>
+            <p:extLst>
+              <p:ext uri="{D42A27DB-BD31-4B8C-83A1-F6EECF244321}">
+                <p14:modId xmlns:p14="http://schemas.microsoft.com/office/powerpoint/2010/main" val="3503196247"/>
+              </p:ext>
+            </p:extLst>
+          </p:nvPr>
+        </p:nvGraphicFramePr>
+        <p:xfrm>
+          <a:off x="441434" y="1608908"/>
+          <a:ext cx="11062421" cy="4537888"/>
+        </p:xfrm>
+        <a:graphic>
+          <a:graphicData uri="http://schemas.openxmlformats.org/drawingml/2006/table">
+            <a:tbl>
+              <a:tblPr/>
+              <a:tblGrid>
+                <a:gridCol w="715660">
+                  <a:extLst>
+                    <a:ext uri="{9D8B030D-6E8A-4147-A177-3AD203B41FA5}">
+                      <a16:colId xmlns:a16="http://schemas.microsoft.com/office/drawing/2014/main" val="2794491609"/>
+                    </a:ext>
+                  </a:extLst>
+                </a:gridCol>
+                <a:gridCol w="1570340">
+                  <a:extLst>
+                    <a:ext uri="{9D8B030D-6E8A-4147-A177-3AD203B41FA5}">
+                      <a16:colId xmlns:a16="http://schemas.microsoft.com/office/drawing/2014/main" val="1747983715"/>
+                    </a:ext>
+                  </a:extLst>
+                </a:gridCol>
+                <a:gridCol w="3436883">
+                  <a:extLst>
+                    <a:ext uri="{9D8B030D-6E8A-4147-A177-3AD203B41FA5}">
+                      <a16:colId xmlns:a16="http://schemas.microsoft.com/office/drawing/2014/main" val="1415124489"/>
+                    </a:ext>
+                  </a:extLst>
+                </a:gridCol>
+                <a:gridCol w="3026980">
+                  <a:extLst>
+                    <a:ext uri="{9D8B030D-6E8A-4147-A177-3AD203B41FA5}">
+                      <a16:colId xmlns:a16="http://schemas.microsoft.com/office/drawing/2014/main" val="917873486"/>
+                    </a:ext>
+                  </a:extLst>
+                </a:gridCol>
+                <a:gridCol w="2312558">
+                  <a:extLst>
+                    <a:ext uri="{9D8B030D-6E8A-4147-A177-3AD203B41FA5}">
+                      <a16:colId xmlns:a16="http://schemas.microsoft.com/office/drawing/2014/main" val="2083092539"/>
+                    </a:ext>
+                  </a:extLst>
+                </a:gridCol>
+              </a:tblGrid>
+              <a:tr h="151505">
+                <a:tc>
+                  <a:txBody>
+                    <a:bodyPr/>
+                    <a:lstStyle/>
+                    <a:p>
+                      <a:r>
+                        <a:rPr lang="en-US" sz="1800" b="1">
+                          <a:effectLst/>
+                        </a:rPr>
+                        <a:t>Week</a:t>
+                      </a:r>
+                      <a:endParaRPr lang="en-US" sz="1800">
+                        <a:effectLst/>
+                      </a:endParaRPr>
+                    </a:p>
+                  </a:txBody>
+                  <a:tcPr marL="4649" marR="4649" marT="4649" marB="4649" anchor="ctr">
+                    <a:lnL>
+                      <a:noFill/>
+                    </a:lnL>
+                    <a:lnR>
+                      <a:noFill/>
+                    </a:lnR>
+                    <a:lnT>
+                      <a:noFill/>
+                    </a:lnT>
+                    <a:lnB>
+                      <a:noFill/>
+                    </a:lnB>
+                    <a:solidFill>
+                      <a:srgbClr val="FFFFFF"/>
+                    </a:solidFill>
+                  </a:tcPr>
+                </a:tc>
+                <a:tc>
+                  <a:txBody>
+                    <a:bodyPr/>
+                    <a:lstStyle/>
+                    <a:p>
+                      <a:r>
+                        <a:rPr lang="en-US" sz="1800" b="1">
+                          <a:effectLst/>
+                        </a:rPr>
+                        <a:t>Date</a:t>
+                      </a:r>
+                      <a:endParaRPr lang="en-US" sz="1800">
+                        <a:effectLst/>
+                      </a:endParaRPr>
+                    </a:p>
+                  </a:txBody>
+                  <a:tcPr marL="4649" marR="4649" marT="4649" marB="4649" anchor="ctr">
+                    <a:lnL>
+                      <a:noFill/>
+                    </a:lnL>
+                    <a:lnR>
+                      <a:noFill/>
+                    </a:lnR>
+                    <a:lnT>
+                      <a:noFill/>
+                    </a:lnT>
+                    <a:lnB>
+                      <a:noFill/>
+                    </a:lnB>
+                    <a:solidFill>
+                      <a:srgbClr val="FFFFFF"/>
+                    </a:solidFill>
+                  </a:tcPr>
+                </a:tc>
+                <a:tc>
+                  <a:txBody>
+                    <a:bodyPr/>
+                    <a:lstStyle/>
+                    <a:p>
+                      <a:r>
+                        <a:rPr lang="en-US" sz="1800" b="1">
+                          <a:effectLst/>
+                        </a:rPr>
+                        <a:t>Topic</a:t>
+                      </a:r>
+                      <a:endParaRPr lang="en-US" sz="1800">
+                        <a:effectLst/>
+                      </a:endParaRPr>
+                    </a:p>
+                  </a:txBody>
+                  <a:tcPr marL="4649" marR="4649" marT="4649" marB="4649" anchor="ctr">
+                    <a:lnL>
+                      <a:noFill/>
+                    </a:lnL>
+                    <a:lnR>
+                      <a:noFill/>
+                    </a:lnR>
+                    <a:lnT>
+                      <a:noFill/>
+                    </a:lnT>
+                    <a:lnB>
+                      <a:noFill/>
+                    </a:lnB>
+                    <a:solidFill>
+                      <a:srgbClr val="FFFFFF"/>
+                    </a:solidFill>
+                  </a:tcPr>
+                </a:tc>
+                <a:tc>
+                  <a:txBody>
+                    <a:bodyPr/>
+                    <a:lstStyle/>
+                    <a:p>
+                      <a:r>
+                        <a:rPr lang="en-US" sz="1800" b="1" dirty="0">
+                          <a:effectLst/>
+                        </a:rPr>
+                        <a:t>In class work</a:t>
+                      </a:r>
+                      <a:endParaRPr lang="en-US" sz="1800" dirty="0">
+                        <a:effectLst/>
+                      </a:endParaRPr>
+                    </a:p>
+                  </a:txBody>
+                  <a:tcPr marL="4649" marR="4649" marT="4649" marB="4649" anchor="ctr">
+                    <a:lnL>
+                      <a:noFill/>
+                    </a:lnL>
+                    <a:lnR>
+                      <a:noFill/>
+                    </a:lnR>
+                    <a:lnT>
+                      <a:noFill/>
+                    </a:lnT>
+                    <a:lnB>
+                      <a:noFill/>
+                    </a:lnB>
+                    <a:solidFill>
+                      <a:srgbClr val="FFFFFF"/>
+                    </a:solidFill>
+                  </a:tcPr>
+                </a:tc>
+                <a:tc>
+                  <a:txBody>
+                    <a:bodyPr/>
+                    <a:lstStyle/>
+                    <a:p>
+                      <a:r>
+                        <a:rPr lang="en-US" sz="1800" b="1" dirty="0">
+                          <a:effectLst/>
+                        </a:rPr>
+                        <a:t>Due date</a:t>
+                      </a:r>
+                    </a:p>
+                  </a:txBody>
+                  <a:tcPr marL="4649" marR="4649" marT="4649" marB="4649" anchor="ctr">
+                    <a:lnL>
+                      <a:noFill/>
+                    </a:lnL>
+                    <a:lnR>
+                      <a:noFill/>
+                    </a:lnR>
+                    <a:lnT>
+                      <a:noFill/>
+                    </a:lnT>
+                    <a:lnB>
+                      <a:noFill/>
+                    </a:lnB>
+                    <a:solidFill>
+                      <a:srgbClr val="FFFFFF"/>
+                    </a:solidFill>
+                  </a:tcPr>
+                </a:tc>
+                <a:extLst>
+                  <a:ext uri="{0D108BD9-81ED-4DB2-BD59-A6C34878D82A}">
+                    <a16:rowId xmlns:a16="http://schemas.microsoft.com/office/drawing/2014/main" val="821601634"/>
+                  </a:ext>
+                </a:extLst>
+              </a:tr>
+              <a:tr h="191244">
+                <a:tc>
+                  <a:txBody>
+                    <a:bodyPr/>
+                    <a:lstStyle/>
+                    <a:p>
+                      <a:r>
+                        <a:rPr lang="en-US" sz="1800" dirty="0">
+                          <a:effectLst/>
+                        </a:rPr>
+                        <a:t>1</a:t>
+                      </a:r>
+                    </a:p>
+                  </a:txBody>
+                  <a:tcPr marL="4649" marR="4649" marT="4649" marB="4649" anchor="ctr">
+                    <a:lnL>
+                      <a:noFill/>
+                    </a:lnL>
+                    <a:lnR>
+                      <a:noFill/>
+                    </a:lnR>
+                    <a:lnT>
+                      <a:noFill/>
+                    </a:lnT>
+                    <a:lnB>
+                      <a:noFill/>
+                    </a:lnB>
+                    <a:solidFill>
+                      <a:srgbClr val="FFFFFF"/>
+                    </a:solidFill>
+                  </a:tcPr>
+                </a:tc>
+                <a:tc>
+                  <a:txBody>
+                    <a:bodyPr/>
+                    <a:lstStyle/>
+                    <a:p>
+                      <a:r>
+                        <a:rPr lang="en-US" sz="1800" dirty="0">
+                          <a:effectLst/>
+                        </a:rPr>
+                        <a:t>8/26/2024</a:t>
+                      </a:r>
+                    </a:p>
+                  </a:txBody>
+                  <a:tcPr marL="4649" marR="4649" marT="4649" marB="4649" anchor="ctr">
+                    <a:lnL>
+                      <a:noFill/>
+                    </a:lnL>
+                    <a:lnR>
+                      <a:noFill/>
+                    </a:lnR>
+                    <a:lnT>
+                      <a:noFill/>
+                    </a:lnT>
+                    <a:lnB>
+                      <a:noFill/>
+                    </a:lnB>
+                    <a:solidFill>
+                      <a:srgbClr val="FFFFFF"/>
+                    </a:solidFill>
+                  </a:tcPr>
+                </a:tc>
+                <a:tc>
+                  <a:txBody>
+                    <a:bodyPr/>
+                    <a:lstStyle/>
+                    <a:p>
+                      <a:r>
+                        <a:rPr lang="en-US" sz="1800" dirty="0">
+                          <a:effectLst/>
+                        </a:rPr>
+                        <a:t>Introduction to course</a:t>
+                      </a:r>
+                    </a:p>
+                  </a:txBody>
+                  <a:tcPr marL="4649" marR="4649" marT="4649" marB="4649" anchor="ctr">
+                    <a:lnL>
+                      <a:noFill/>
+                    </a:lnL>
+                    <a:lnR>
+                      <a:noFill/>
+                    </a:lnR>
+                    <a:lnT>
+                      <a:noFill/>
+                    </a:lnT>
+                    <a:lnB>
+                      <a:noFill/>
+                    </a:lnB>
+                    <a:solidFill>
+                      <a:srgbClr val="FFFFFF"/>
+                    </a:solidFill>
+                  </a:tcPr>
+                </a:tc>
+                <a:tc>
+                  <a:txBody>
+                    <a:bodyPr/>
+                    <a:lstStyle/>
+                    <a:p>
+                      <a:r>
+                        <a:rPr lang="en-US" sz="1800" dirty="0">
+                          <a:effectLst/>
+                        </a:rPr>
+                        <a:t>Intro to OpenCV  </a:t>
+                      </a:r>
+                    </a:p>
+                  </a:txBody>
+                  <a:tcPr marL="4649" marR="4649" marT="4649" marB="4649" anchor="ctr">
+                    <a:lnL>
+                      <a:noFill/>
+                    </a:lnL>
+                    <a:lnR>
+                      <a:noFill/>
+                    </a:lnR>
+                    <a:lnT>
+                      <a:noFill/>
+                    </a:lnT>
+                    <a:lnB>
+                      <a:noFill/>
+                    </a:lnB>
+                    <a:solidFill>
+                      <a:srgbClr val="FFFFFF"/>
+                    </a:solidFill>
+                  </a:tcPr>
+                </a:tc>
+                <a:tc>
+                  <a:txBody>
+                    <a:bodyPr/>
+                    <a:lstStyle/>
+                    <a:p>
+                      <a:endParaRPr lang="en-US" sz="1800" dirty="0">
+                        <a:effectLst/>
+                      </a:endParaRPr>
+                    </a:p>
+                  </a:txBody>
+                  <a:tcPr marL="4649" marR="4649" marT="4649" marB="4649" anchor="ctr">
+                    <a:lnL>
+                      <a:noFill/>
+                    </a:lnL>
+                    <a:lnR>
+                      <a:noFill/>
+                    </a:lnR>
+                    <a:lnT>
+                      <a:noFill/>
+                    </a:lnT>
+                    <a:lnB>
+                      <a:noFill/>
+                    </a:lnB>
+                    <a:solidFill>
+                      <a:srgbClr val="FFFFFF"/>
+                    </a:solidFill>
+                  </a:tcPr>
+                </a:tc>
+                <a:extLst>
+                  <a:ext uri="{0D108BD9-81ED-4DB2-BD59-A6C34878D82A}">
+                    <a16:rowId xmlns:a16="http://schemas.microsoft.com/office/drawing/2014/main" val="3824158272"/>
+                  </a:ext>
+                </a:extLst>
+              </a:tr>
+              <a:tr h="101831">
+                <a:tc>
+                  <a:txBody>
+                    <a:bodyPr/>
+                    <a:lstStyle/>
+                    <a:p>
+                      <a:r>
+                        <a:rPr lang="en-US" sz="1800">
+                          <a:effectLst/>
+                        </a:rPr>
+                        <a:t> </a:t>
+                      </a:r>
+                    </a:p>
+                  </a:txBody>
+                  <a:tcPr marL="4649" marR="4649" marT="4649" marB="4649" anchor="ctr">
+                    <a:lnL>
+                      <a:noFill/>
+                    </a:lnL>
+                    <a:lnR>
+                      <a:noFill/>
+                    </a:lnR>
+                    <a:lnT>
+                      <a:noFill/>
+                    </a:lnT>
+                    <a:lnB>
+                      <a:noFill/>
+                    </a:lnB>
+                    <a:solidFill>
+                      <a:srgbClr val="FFFFFF"/>
+                    </a:solidFill>
+                  </a:tcPr>
+                </a:tc>
+                <a:tc>
+                  <a:txBody>
+                    <a:bodyPr/>
+                    <a:lstStyle/>
+                    <a:p>
+                      <a:r>
+                        <a:rPr lang="en-US" sz="1800">
+                          <a:effectLst/>
+                        </a:rPr>
+                        <a:t>8/28/2024</a:t>
+                      </a:r>
+                    </a:p>
+                  </a:txBody>
+                  <a:tcPr marL="4649" marR="4649" marT="4649" marB="4649" anchor="ctr">
+                    <a:lnL>
+                      <a:noFill/>
+                    </a:lnL>
+                    <a:lnR>
+                      <a:noFill/>
+                    </a:lnR>
+                    <a:lnT>
+                      <a:noFill/>
+                    </a:lnT>
+                    <a:lnB>
+                      <a:noFill/>
+                    </a:lnB>
+                    <a:solidFill>
+                      <a:srgbClr val="FFFFFF"/>
+                    </a:solidFill>
+                  </a:tcPr>
+                </a:tc>
+                <a:tc>
+                  <a:txBody>
+                    <a:bodyPr/>
+                    <a:lstStyle/>
+                    <a:p>
+                      <a:r>
+                        <a:rPr lang="en-US" sz="1800" dirty="0">
+                          <a:effectLst/>
+                        </a:rPr>
+                        <a:t>Image operations</a:t>
+                      </a:r>
+                    </a:p>
+                  </a:txBody>
+                  <a:tcPr marL="4649" marR="4649" marT="4649" marB="4649" anchor="ctr">
+                    <a:lnL>
+                      <a:noFill/>
+                    </a:lnL>
+                    <a:lnR>
+                      <a:noFill/>
+                    </a:lnR>
+                    <a:lnT>
+                      <a:noFill/>
+                    </a:lnT>
+                    <a:lnB>
+                      <a:noFill/>
+                    </a:lnB>
+                    <a:solidFill>
+                      <a:srgbClr val="FFFFFF"/>
+                    </a:solidFill>
+                  </a:tcPr>
+                </a:tc>
+                <a:tc>
+                  <a:txBody>
+                    <a:bodyPr/>
+                    <a:lstStyle/>
+                    <a:p>
+                      <a:r>
+                        <a:rPr lang="en-US" sz="1800" dirty="0">
+                          <a:effectLst/>
+                        </a:rPr>
+                        <a:t>Planning projects</a:t>
+                      </a:r>
+                    </a:p>
+                  </a:txBody>
+                  <a:tcPr marL="4649" marR="4649" marT="4649" marB="4649" anchor="ctr">
+                    <a:lnL>
+                      <a:noFill/>
+                    </a:lnL>
+                    <a:lnR>
+                      <a:noFill/>
+                    </a:lnR>
+                    <a:lnT>
+                      <a:noFill/>
+                    </a:lnT>
+                    <a:lnB>
+                      <a:noFill/>
+                    </a:lnB>
+                    <a:solidFill>
+                      <a:srgbClr val="FFFFFF"/>
+                    </a:solidFill>
+                  </a:tcPr>
+                </a:tc>
+                <a:tc>
+                  <a:txBody>
+                    <a:bodyPr/>
+                    <a:lstStyle/>
+                    <a:p>
+                      <a:endParaRPr lang="en-US" sz="1800" dirty="0">
+                        <a:effectLst/>
+                      </a:endParaRPr>
+                    </a:p>
+                  </a:txBody>
+                  <a:tcPr marL="4649" marR="4649" marT="4649" marB="4649" anchor="ctr">
+                    <a:lnL>
+                      <a:noFill/>
+                    </a:lnL>
+                    <a:lnR>
+                      <a:noFill/>
+                    </a:lnR>
+                    <a:lnT>
+                      <a:noFill/>
+                    </a:lnT>
+                    <a:lnB>
+                      <a:noFill/>
+                    </a:lnB>
+                    <a:solidFill>
+                      <a:srgbClr val="FFFFFF"/>
+                    </a:solidFill>
+                  </a:tcPr>
+                </a:tc>
+                <a:extLst>
+                  <a:ext uri="{0D108BD9-81ED-4DB2-BD59-A6C34878D82A}">
+                    <a16:rowId xmlns:a16="http://schemas.microsoft.com/office/drawing/2014/main" val="5361792"/>
+                  </a:ext>
+                </a:extLst>
+              </a:tr>
+              <a:tr h="191244">
+                <a:tc>
+                  <a:txBody>
+                    <a:bodyPr/>
+                    <a:lstStyle/>
+                    <a:p>
+                      <a:r>
+                        <a:rPr lang="en-US" sz="1800" dirty="0">
+                          <a:effectLst/>
+                        </a:rPr>
+                        <a:t>2</a:t>
+                      </a:r>
+                    </a:p>
+                  </a:txBody>
+                  <a:tcPr marL="4649" marR="4649" marT="4649" marB="4649" anchor="ctr">
+                    <a:lnL>
+                      <a:noFill/>
+                    </a:lnL>
+                    <a:lnR>
+                      <a:noFill/>
+                    </a:lnR>
+                    <a:lnT>
+                      <a:noFill/>
+                    </a:lnT>
+                    <a:lnB>
+                      <a:noFill/>
+                    </a:lnB>
+                    <a:solidFill>
+                      <a:srgbClr val="FFFFFF"/>
+                    </a:solidFill>
+                  </a:tcPr>
+                </a:tc>
+                <a:tc>
+                  <a:txBody>
+                    <a:bodyPr/>
+                    <a:lstStyle/>
+                    <a:p>
+                      <a:r>
+                        <a:rPr lang="en-US" sz="1800">
+                          <a:effectLst/>
+                        </a:rPr>
+                        <a:t>9/2/2024</a:t>
+                      </a:r>
+                    </a:p>
+                  </a:txBody>
+                  <a:tcPr marL="4649" marR="4649" marT="4649" marB="4649" anchor="ctr">
+                    <a:lnL>
+                      <a:noFill/>
+                    </a:lnL>
+                    <a:lnR>
+                      <a:noFill/>
+                    </a:lnR>
+                    <a:lnT>
+                      <a:noFill/>
+                    </a:lnT>
+                    <a:lnB>
+                      <a:noFill/>
+                    </a:lnB>
+                    <a:solidFill>
+                      <a:srgbClr val="FFFFFF"/>
+                    </a:solidFill>
+                  </a:tcPr>
+                </a:tc>
+                <a:tc>
+                  <a:txBody>
+                    <a:bodyPr/>
+                    <a:lstStyle/>
+                    <a:p>
+                      <a:r>
+                        <a:rPr lang="en-US" sz="1800" dirty="0">
+                          <a:effectLst/>
+                        </a:rPr>
+                        <a:t>Labor Day [No Class]</a:t>
+                      </a:r>
+                    </a:p>
+                  </a:txBody>
+                  <a:tcPr marL="4649" marR="4649" marT="4649" marB="4649" anchor="ctr">
+                    <a:lnL>
+                      <a:noFill/>
+                    </a:lnL>
+                    <a:lnR>
+                      <a:noFill/>
+                    </a:lnR>
+                    <a:lnT>
+                      <a:noFill/>
+                    </a:lnT>
+                    <a:lnB>
+                      <a:noFill/>
+                    </a:lnB>
+                    <a:solidFill>
+                      <a:srgbClr val="FFFFFF"/>
+                    </a:solidFill>
+                  </a:tcPr>
+                </a:tc>
+                <a:tc>
+                  <a:txBody>
+                    <a:bodyPr/>
+                    <a:lstStyle/>
+                    <a:p>
+                      <a:endParaRPr lang="en-US" sz="1800" dirty="0">
+                        <a:effectLst/>
+                      </a:endParaRPr>
+                    </a:p>
+                  </a:txBody>
+                  <a:tcPr marL="4649" marR="4649" marT="4649" marB="4649" anchor="ctr">
+                    <a:lnL>
+                      <a:noFill/>
+                    </a:lnL>
+                    <a:lnR>
+                      <a:noFill/>
+                    </a:lnR>
+                    <a:lnT>
+                      <a:noFill/>
+                    </a:lnT>
+                    <a:lnB>
+                      <a:noFill/>
+                    </a:lnB>
+                    <a:solidFill>
+                      <a:srgbClr val="FFFFFF"/>
+                    </a:solidFill>
+                  </a:tcPr>
+                </a:tc>
+                <a:tc>
+                  <a:txBody>
+                    <a:bodyPr/>
+                    <a:lstStyle/>
+                    <a:p>
+                      <a:endParaRPr lang="en-US" sz="1800" dirty="0">
+                        <a:effectLst/>
+                      </a:endParaRPr>
+                    </a:p>
+                  </a:txBody>
+                  <a:tcPr marL="4649" marR="4649" marT="4649" marB="4649" anchor="ctr">
+                    <a:lnL>
+                      <a:noFill/>
+                    </a:lnL>
+                    <a:lnR>
+                      <a:noFill/>
+                    </a:lnR>
+                    <a:lnT>
+                      <a:noFill/>
+                    </a:lnT>
+                    <a:lnB>
+                      <a:noFill/>
+                    </a:lnB>
+                    <a:solidFill>
+                      <a:srgbClr val="FFFFFF"/>
+                    </a:solidFill>
+                  </a:tcPr>
+                </a:tc>
+                <a:extLst>
+                  <a:ext uri="{0D108BD9-81ED-4DB2-BD59-A6C34878D82A}">
+                    <a16:rowId xmlns:a16="http://schemas.microsoft.com/office/drawing/2014/main" val="667319350"/>
+                  </a:ext>
+                </a:extLst>
+              </a:tr>
+              <a:tr h="191244">
+                <a:tc>
+                  <a:txBody>
+                    <a:bodyPr/>
+                    <a:lstStyle/>
+                    <a:p>
+                      <a:r>
+                        <a:rPr lang="en-US" sz="1800">
+                          <a:effectLst/>
+                        </a:rPr>
+                        <a:t> </a:t>
+                      </a:r>
+                    </a:p>
+                  </a:txBody>
+                  <a:tcPr marL="4649" marR="4649" marT="4649" marB="4649" anchor="ctr">
+                    <a:lnL>
+                      <a:noFill/>
+                    </a:lnL>
+                    <a:lnR>
+                      <a:noFill/>
+                    </a:lnR>
+                    <a:lnT>
+                      <a:noFill/>
+                    </a:lnT>
+                    <a:lnB>
+                      <a:noFill/>
+                    </a:lnB>
+                    <a:solidFill>
+                      <a:srgbClr val="FFFFFF"/>
+                    </a:solidFill>
+                  </a:tcPr>
+                </a:tc>
+                <a:tc>
+                  <a:txBody>
+                    <a:bodyPr/>
+                    <a:lstStyle/>
+                    <a:p>
+                      <a:r>
+                        <a:rPr lang="en-US" sz="1800">
+                          <a:effectLst/>
+                        </a:rPr>
+                        <a:t>9/4/2024</a:t>
+                      </a:r>
+                    </a:p>
+                  </a:txBody>
+                  <a:tcPr marL="4649" marR="4649" marT="4649" marB="4649" anchor="ctr">
+                    <a:lnL>
+                      <a:noFill/>
+                    </a:lnL>
+                    <a:lnR>
+                      <a:noFill/>
+                    </a:lnR>
+                    <a:lnT>
+                      <a:noFill/>
+                    </a:lnT>
+                    <a:lnB>
+                      <a:noFill/>
+                    </a:lnB>
+                    <a:solidFill>
+                      <a:srgbClr val="FFFFFF"/>
+                    </a:solidFill>
+                  </a:tcPr>
+                </a:tc>
+                <a:tc>
+                  <a:txBody>
+                    <a:bodyPr/>
+                    <a:lstStyle/>
+                    <a:p>
+                      <a:r>
+                        <a:rPr lang="en-US" sz="1800" dirty="0">
+                          <a:effectLst/>
+                        </a:rPr>
+                        <a:t>Analysis and Color spaces</a:t>
+                      </a:r>
+                    </a:p>
+                  </a:txBody>
+                  <a:tcPr marL="4649" marR="4649" marT="4649" marB="4649" anchor="ctr">
+                    <a:lnL>
+                      <a:noFill/>
+                    </a:lnL>
+                    <a:lnR>
+                      <a:noFill/>
+                    </a:lnR>
+                    <a:lnT>
+                      <a:noFill/>
+                    </a:lnT>
+                    <a:lnB>
+                      <a:noFill/>
+                    </a:lnB>
+                    <a:solidFill>
+                      <a:srgbClr val="FFFFFF"/>
+                    </a:solidFill>
+                  </a:tcPr>
+                </a:tc>
+                <a:tc>
+                  <a:txBody>
+                    <a:bodyPr/>
+                    <a:lstStyle/>
+                    <a:p>
+                      <a:r>
+                        <a:rPr lang="en-US" sz="1800" dirty="0">
+                          <a:effectLst/>
+                        </a:rPr>
+                        <a:t>Initial project proposal</a:t>
+                      </a:r>
+                    </a:p>
+                  </a:txBody>
+                  <a:tcPr marL="4649" marR="4649" marT="4649" marB="4649" anchor="ctr">
+                    <a:lnL>
+                      <a:noFill/>
+                    </a:lnL>
+                    <a:lnR>
+                      <a:noFill/>
+                    </a:lnR>
+                    <a:lnT>
+                      <a:noFill/>
+                    </a:lnT>
+                    <a:lnB>
+                      <a:noFill/>
+                    </a:lnB>
+                    <a:solidFill>
+                      <a:srgbClr val="FFFFFF"/>
+                    </a:solidFill>
+                  </a:tcPr>
+                </a:tc>
+                <a:tc>
+                  <a:txBody>
+                    <a:bodyPr/>
+                    <a:lstStyle/>
+                    <a:p>
+                      <a:endParaRPr lang="en-US" sz="1800" dirty="0">
+                        <a:effectLst/>
+                      </a:endParaRPr>
+                    </a:p>
+                  </a:txBody>
+                  <a:tcPr marL="4649" marR="4649" marT="4649" marB="4649" anchor="ctr">
+                    <a:lnL>
+                      <a:noFill/>
+                    </a:lnL>
+                    <a:lnR>
+                      <a:noFill/>
+                    </a:lnR>
+                    <a:lnT>
+                      <a:noFill/>
+                    </a:lnT>
+                    <a:lnB>
+                      <a:noFill/>
+                    </a:lnB>
+                    <a:solidFill>
+                      <a:srgbClr val="FFFFFF"/>
+                    </a:solidFill>
+                  </a:tcPr>
+                </a:tc>
+                <a:extLst>
+                  <a:ext uri="{0D108BD9-81ED-4DB2-BD59-A6C34878D82A}">
+                    <a16:rowId xmlns:a16="http://schemas.microsoft.com/office/drawing/2014/main" val="3945893794"/>
+                  </a:ext>
+                </a:extLst>
+              </a:tr>
+              <a:tr h="191244">
+                <a:tc>
+                  <a:txBody>
+                    <a:bodyPr/>
+                    <a:lstStyle/>
+                    <a:p>
+                      <a:r>
+                        <a:rPr lang="en-US" sz="1800" dirty="0">
+                          <a:effectLst/>
+                        </a:rPr>
+                        <a:t>3</a:t>
+                      </a:r>
+                    </a:p>
+                  </a:txBody>
+                  <a:tcPr marL="4649" marR="4649" marT="4649" marB="4649" anchor="ctr">
+                    <a:lnL>
+                      <a:noFill/>
+                    </a:lnL>
+                    <a:lnR>
+                      <a:noFill/>
+                    </a:lnR>
+                    <a:lnT>
+                      <a:noFill/>
+                    </a:lnT>
+                    <a:lnB>
+                      <a:noFill/>
+                    </a:lnB>
+                    <a:solidFill>
+                      <a:srgbClr val="FFFFFF"/>
+                    </a:solidFill>
+                  </a:tcPr>
+                </a:tc>
+                <a:tc>
+                  <a:txBody>
+                    <a:bodyPr/>
+                    <a:lstStyle/>
+                    <a:p>
+                      <a:r>
+                        <a:rPr lang="en-US" sz="1800" dirty="0">
+                          <a:effectLst/>
+                        </a:rPr>
+                        <a:t>9/9/2024.  </a:t>
+                      </a:r>
+                      <a:r>
+                        <a:rPr lang="en-US" sz="1800" dirty="0">
+                          <a:solidFill>
+                            <a:srgbClr val="C00000"/>
+                          </a:solidFill>
+                          <a:effectLst/>
+                        </a:rPr>
+                        <a:t>*</a:t>
+                      </a:r>
+                    </a:p>
+                  </a:txBody>
+                  <a:tcPr marL="4649" marR="4649" marT="4649" marB="4649" anchor="ctr">
+                    <a:lnL>
+                      <a:noFill/>
+                    </a:lnL>
+                    <a:lnR>
+                      <a:noFill/>
+                    </a:lnR>
+                    <a:lnT>
+                      <a:noFill/>
+                    </a:lnT>
+                    <a:lnB>
+                      <a:noFill/>
+                    </a:lnB>
+                    <a:solidFill>
+                      <a:srgbClr val="FFFFFF"/>
+                    </a:solidFill>
+                  </a:tcPr>
+                </a:tc>
+                <a:tc>
+                  <a:txBody>
+                    <a:bodyPr/>
+                    <a:lstStyle/>
+                    <a:p>
+                      <a:r>
+                        <a:rPr lang="en-US" sz="1800" dirty="0">
+                          <a:effectLst/>
+                        </a:rPr>
+                        <a:t>Transforms (DFT, </a:t>
+                      </a:r>
+                      <a:r>
+                        <a:rPr lang="en-US" sz="1800" dirty="0" err="1">
+                          <a:effectLst/>
+                        </a:rPr>
+                        <a:t>Haar</a:t>
+                      </a:r>
+                      <a:r>
+                        <a:rPr lang="en-US" sz="1800" dirty="0">
+                          <a:effectLst/>
+                        </a:rPr>
+                        <a:t>, Walsh)</a:t>
+                      </a:r>
+                    </a:p>
+                  </a:txBody>
+                  <a:tcPr marL="4649" marR="4649" marT="4649" marB="4649" anchor="ctr">
+                    <a:lnL>
+                      <a:noFill/>
+                    </a:lnL>
+                    <a:lnR>
+                      <a:noFill/>
+                    </a:lnR>
+                    <a:lnT>
+                      <a:noFill/>
+                    </a:lnT>
+                    <a:lnB>
+                      <a:noFill/>
+                    </a:lnB>
+                    <a:solidFill>
+                      <a:srgbClr val="FFFFFF"/>
+                    </a:solidFill>
+                  </a:tcPr>
+                </a:tc>
+                <a:tc>
+                  <a:txBody>
+                    <a:bodyPr/>
+                    <a:lstStyle/>
+                    <a:p>
+                      <a:r>
+                        <a:rPr lang="en-US" sz="1800" dirty="0">
+                          <a:effectLst/>
+                        </a:rPr>
+                        <a:t>Initial project proposal</a:t>
+                      </a:r>
+                    </a:p>
+                  </a:txBody>
+                  <a:tcPr marL="4649" marR="4649" marT="4649" marB="4649" anchor="ctr">
+                    <a:lnL>
+                      <a:noFill/>
+                    </a:lnL>
+                    <a:lnR>
+                      <a:noFill/>
+                    </a:lnR>
+                    <a:lnT>
+                      <a:noFill/>
+                    </a:lnT>
+                    <a:lnB>
+                      <a:noFill/>
+                    </a:lnB>
+                    <a:solidFill>
+                      <a:srgbClr val="FFFFFF"/>
+                    </a:solidFill>
+                  </a:tcPr>
+                </a:tc>
+                <a:tc>
+                  <a:txBody>
+                    <a:bodyPr/>
+                    <a:lstStyle/>
+                    <a:p>
+                      <a:r>
+                        <a:rPr lang="en-US" sz="1800" dirty="0">
+                          <a:effectLst/>
+                        </a:rPr>
+                        <a:t>HW 1 Due 9/16</a:t>
+                      </a:r>
+                    </a:p>
+                  </a:txBody>
+                  <a:tcPr marL="4649" marR="4649" marT="4649" marB="4649" anchor="ctr">
+                    <a:lnL>
+                      <a:noFill/>
+                    </a:lnL>
+                    <a:lnR>
+                      <a:noFill/>
+                    </a:lnR>
+                    <a:lnT>
+                      <a:noFill/>
+                    </a:lnT>
+                    <a:lnB>
+                      <a:noFill/>
+                    </a:lnB>
+                    <a:solidFill>
+                      <a:srgbClr val="FFFFFF"/>
+                    </a:solidFill>
+                  </a:tcPr>
+                </a:tc>
+                <a:extLst>
+                  <a:ext uri="{0D108BD9-81ED-4DB2-BD59-A6C34878D82A}">
+                    <a16:rowId xmlns:a16="http://schemas.microsoft.com/office/drawing/2014/main" val="3111691061"/>
+                  </a:ext>
+                </a:extLst>
+              </a:tr>
+              <a:tr h="191244">
+                <a:tc>
+                  <a:txBody>
+                    <a:bodyPr/>
+                    <a:lstStyle/>
+                    <a:p>
+                      <a:r>
+                        <a:rPr lang="en-US" sz="1800" dirty="0">
+                          <a:effectLst/>
+                        </a:rPr>
+                        <a:t> </a:t>
+                      </a:r>
+                    </a:p>
+                  </a:txBody>
+                  <a:tcPr marL="4649" marR="4649" marT="4649" marB="4649" anchor="ctr">
+                    <a:lnL>
+                      <a:noFill/>
+                    </a:lnL>
+                    <a:lnR>
+                      <a:noFill/>
+                    </a:lnR>
+                    <a:lnT>
+                      <a:noFill/>
+                    </a:lnT>
+                    <a:lnB>
+                      <a:noFill/>
+                    </a:lnB>
+                    <a:solidFill>
+                      <a:srgbClr val="FFFFFF"/>
+                    </a:solidFill>
+                  </a:tcPr>
+                </a:tc>
+                <a:tc>
+                  <a:txBody>
+                    <a:bodyPr/>
+                    <a:lstStyle/>
+                    <a:p>
+                      <a:r>
+                        <a:rPr lang="en-US" sz="1800" dirty="0">
+                          <a:effectLst/>
+                        </a:rPr>
+                        <a:t>9/11/2024 </a:t>
+                      </a:r>
+                      <a:r>
+                        <a:rPr lang="en-US" sz="1800" dirty="0">
+                          <a:solidFill>
+                            <a:srgbClr val="C00000"/>
+                          </a:solidFill>
+                          <a:effectLst/>
+                        </a:rPr>
+                        <a:t>*</a:t>
+                      </a:r>
+                    </a:p>
+                  </a:txBody>
+                  <a:tcPr marL="4649" marR="4649" marT="4649" marB="4649" anchor="ctr">
+                    <a:lnL>
+                      <a:noFill/>
+                    </a:lnL>
+                    <a:lnR>
+                      <a:noFill/>
+                    </a:lnR>
+                    <a:lnT>
+                      <a:noFill/>
+                    </a:lnT>
+                    <a:lnB>
+                      <a:noFill/>
+                    </a:lnB>
+                    <a:solidFill>
+                      <a:srgbClr val="FFFFFF"/>
+                    </a:solidFill>
+                  </a:tcPr>
+                </a:tc>
+                <a:tc>
+                  <a:txBody>
+                    <a:bodyPr/>
+                    <a:lstStyle/>
+                    <a:p>
+                      <a:r>
+                        <a:rPr lang="en-US" sz="1800" dirty="0">
+                          <a:effectLst/>
+                        </a:rPr>
+                        <a:t>Spatial &amp; Frequency Filtering</a:t>
+                      </a:r>
+                    </a:p>
+                  </a:txBody>
+                  <a:tcPr marL="4649" marR="4649" marT="4649" marB="4649" anchor="ctr">
+                    <a:lnL>
+                      <a:noFill/>
+                    </a:lnL>
+                    <a:lnR>
+                      <a:noFill/>
+                    </a:lnR>
+                    <a:lnT>
+                      <a:noFill/>
+                    </a:lnT>
+                    <a:lnB>
+                      <a:noFill/>
+                    </a:lnB>
+                    <a:solidFill>
+                      <a:srgbClr val="FFFFFF"/>
+                    </a:solidFill>
+                  </a:tcPr>
+                </a:tc>
+                <a:tc>
+                  <a:txBody>
+                    <a:bodyPr/>
+                    <a:lstStyle/>
+                    <a:p>
+                      <a:r>
+                        <a:rPr lang="en-US" sz="1800" dirty="0">
+                          <a:effectLst/>
+                        </a:rPr>
+                        <a:t>Python problems (HW1)</a:t>
+                      </a:r>
+                    </a:p>
+                  </a:txBody>
+                  <a:tcPr marL="4649" marR="4649" marT="4649" marB="4649" anchor="ctr">
+                    <a:lnL>
+                      <a:noFill/>
+                    </a:lnL>
+                    <a:lnR>
+                      <a:noFill/>
+                    </a:lnR>
+                    <a:lnT>
+                      <a:noFill/>
+                    </a:lnT>
+                    <a:lnB>
+                      <a:noFill/>
+                    </a:lnB>
+                    <a:solidFill>
+                      <a:srgbClr val="FFFFFF"/>
+                    </a:solidFill>
+                  </a:tcPr>
+                </a:tc>
+                <a:tc>
+                  <a:txBody>
+                    <a:bodyPr/>
+                    <a:lstStyle/>
+                    <a:p>
+                      <a:endParaRPr lang="en-US" sz="1800" dirty="0">
+                        <a:effectLst/>
+                      </a:endParaRPr>
+                    </a:p>
+                  </a:txBody>
+                  <a:tcPr marL="4649" marR="4649" marT="4649" marB="4649" anchor="ctr">
+                    <a:lnL>
+                      <a:noFill/>
+                    </a:lnL>
+                    <a:lnR>
+                      <a:noFill/>
+                    </a:lnR>
+                    <a:lnT>
+                      <a:noFill/>
+                    </a:lnT>
+                    <a:lnB>
+                      <a:noFill/>
+                    </a:lnB>
+                    <a:solidFill>
+                      <a:srgbClr val="FFFFFF"/>
+                    </a:solidFill>
+                  </a:tcPr>
+                </a:tc>
+                <a:extLst>
+                  <a:ext uri="{0D108BD9-81ED-4DB2-BD59-A6C34878D82A}">
+                    <a16:rowId xmlns:a16="http://schemas.microsoft.com/office/drawing/2014/main" val="2448716580"/>
+                  </a:ext>
+                </a:extLst>
+              </a:tr>
+              <a:tr h="280658">
+                <a:tc>
+                  <a:txBody>
+                    <a:bodyPr/>
+                    <a:lstStyle/>
+                    <a:p>
+                      <a:r>
+                        <a:rPr lang="en-US" sz="1800" dirty="0">
+                          <a:effectLst/>
+                        </a:rPr>
+                        <a:t>4</a:t>
+                      </a:r>
+                    </a:p>
+                  </a:txBody>
+                  <a:tcPr marL="4649" marR="4649" marT="4649" marB="4649" anchor="ctr">
+                    <a:lnL>
+                      <a:noFill/>
+                    </a:lnL>
+                    <a:lnR>
+                      <a:noFill/>
+                    </a:lnR>
+                    <a:lnT>
+                      <a:noFill/>
+                    </a:lnT>
+                    <a:lnB>
+                      <a:noFill/>
+                    </a:lnB>
+                    <a:solidFill>
+                      <a:srgbClr val="FFFFFF"/>
+                    </a:solidFill>
+                  </a:tcPr>
+                </a:tc>
+                <a:tc>
+                  <a:txBody>
+                    <a:bodyPr/>
+                    <a:lstStyle/>
+                    <a:p>
+                      <a:r>
+                        <a:rPr lang="en-US" sz="1800" dirty="0">
+                          <a:effectLst/>
+                        </a:rPr>
+                        <a:t>9/16/2024 </a:t>
+                      </a:r>
+                      <a:r>
+                        <a:rPr lang="en-US" sz="1800" dirty="0">
+                          <a:solidFill>
+                            <a:srgbClr val="C00000"/>
+                          </a:solidFill>
+                          <a:effectLst/>
+                        </a:rPr>
+                        <a:t>**</a:t>
+                      </a:r>
+                    </a:p>
+                  </a:txBody>
+                  <a:tcPr marL="4649" marR="4649" marT="4649" marB="4649" anchor="ctr">
+                    <a:lnL>
+                      <a:noFill/>
+                    </a:lnL>
+                    <a:lnR>
+                      <a:noFill/>
+                    </a:lnR>
+                    <a:lnT>
+                      <a:noFill/>
+                    </a:lnT>
+                    <a:lnB>
+                      <a:noFill/>
+                    </a:lnB>
+                    <a:solidFill>
+                      <a:srgbClr val="FFFFFF"/>
+                    </a:solidFill>
+                  </a:tcPr>
+                </a:tc>
+                <a:tc>
+                  <a:txBody>
+                    <a:bodyPr/>
+                    <a:lstStyle/>
+                    <a:p>
+                      <a:pPr marL="0" marR="0" lvl="0" indent="0" algn="l" defTabSz="914400" rtl="0" eaLnBrk="1" fontAlgn="auto" latinLnBrk="0" hangingPunct="1">
+                        <a:lnSpc>
+                          <a:spcPct val="100000"/>
+                        </a:lnSpc>
+                        <a:spcBef>
+                          <a:spcPts val="0"/>
+                        </a:spcBef>
+                        <a:spcAft>
+                          <a:spcPts val="0"/>
+                        </a:spcAft>
+                        <a:buClrTx/>
+                        <a:buSzTx/>
+                        <a:buFontTx/>
+                        <a:buNone/>
+                        <a:tabLst/>
+                        <a:defRPr/>
+                      </a:pPr>
+                      <a:r>
+                        <a:rPr lang="en-US" sz="1800" dirty="0">
+                          <a:effectLst/>
+                        </a:rPr>
+                        <a:t>Group Project work </a:t>
+                      </a:r>
+                    </a:p>
+                  </a:txBody>
+                  <a:tcPr marL="4649" marR="4649" marT="4649" marB="4649" anchor="ctr">
+                    <a:lnL>
+                      <a:noFill/>
+                    </a:lnL>
+                    <a:lnR>
+                      <a:noFill/>
+                    </a:lnR>
+                    <a:lnT>
+                      <a:noFill/>
+                    </a:lnT>
+                    <a:lnB>
+                      <a:noFill/>
+                    </a:lnB>
+                    <a:solidFill>
+                      <a:srgbClr val="FFFFFF"/>
+                    </a:solidFill>
+                  </a:tcPr>
+                </a:tc>
+                <a:tc>
+                  <a:txBody>
+                    <a:bodyPr/>
+                    <a:lstStyle/>
+                    <a:p>
+                      <a:r>
+                        <a:rPr lang="en-US" sz="1800" dirty="0">
+                          <a:effectLst/>
+                        </a:rPr>
+                        <a:t>Python problems (HW2)</a:t>
+                      </a:r>
+                    </a:p>
+                  </a:txBody>
+                  <a:tcPr marL="4649" marR="4649" marT="4649" marB="4649" anchor="ctr">
+                    <a:lnL>
+                      <a:noFill/>
+                    </a:lnL>
+                    <a:lnR>
+                      <a:noFill/>
+                    </a:lnR>
+                    <a:lnT>
+                      <a:noFill/>
+                    </a:lnT>
+                    <a:lnB>
+                      <a:noFill/>
+                    </a:lnB>
+                    <a:solidFill>
+                      <a:srgbClr val="FFFFFF"/>
+                    </a:solidFill>
+                  </a:tcPr>
+                </a:tc>
+                <a:tc>
+                  <a:txBody>
+                    <a:bodyPr/>
+                    <a:lstStyle/>
+                    <a:p>
+                      <a:pPr marL="0" marR="0" lvl="0" indent="0" algn="l" defTabSz="914400" rtl="0" eaLnBrk="1" fontAlgn="auto" latinLnBrk="0" hangingPunct="1">
+                        <a:lnSpc>
+                          <a:spcPct val="100000"/>
+                        </a:lnSpc>
+                        <a:spcBef>
+                          <a:spcPts val="0"/>
+                        </a:spcBef>
+                        <a:spcAft>
+                          <a:spcPts val="0"/>
+                        </a:spcAft>
+                        <a:buClrTx/>
+                        <a:buSzTx/>
+                        <a:buFontTx/>
+                        <a:buNone/>
+                        <a:tabLst/>
+                        <a:defRPr/>
+                      </a:pPr>
+                      <a:r>
+                        <a:rPr lang="en-US" sz="1800" dirty="0">
+                          <a:effectLst/>
+                        </a:rPr>
+                        <a:t>HW 2 Due 9/23 </a:t>
+                      </a:r>
+                    </a:p>
+                  </a:txBody>
+                  <a:tcPr marL="4649" marR="4649" marT="4649" marB="4649" anchor="ctr">
+                    <a:lnL>
+                      <a:noFill/>
+                    </a:lnL>
+                    <a:lnR>
+                      <a:noFill/>
+                    </a:lnR>
+                    <a:lnT>
+                      <a:noFill/>
+                    </a:lnT>
+                    <a:lnB>
+                      <a:noFill/>
+                    </a:lnB>
+                    <a:solidFill>
+                      <a:srgbClr val="FFFFFF"/>
+                    </a:solidFill>
+                  </a:tcPr>
+                </a:tc>
+                <a:extLst>
+                  <a:ext uri="{0D108BD9-81ED-4DB2-BD59-A6C34878D82A}">
+                    <a16:rowId xmlns:a16="http://schemas.microsoft.com/office/drawing/2014/main" val="2780081299"/>
+                  </a:ext>
+                </a:extLst>
+              </a:tr>
+              <a:tr h="191244">
+                <a:tc>
+                  <a:txBody>
+                    <a:bodyPr/>
+                    <a:lstStyle/>
+                    <a:p>
+                      <a:r>
+                        <a:rPr lang="en-US" sz="1800">
+                          <a:effectLst/>
+                        </a:rPr>
+                        <a:t> </a:t>
+                      </a:r>
+                    </a:p>
+                  </a:txBody>
+                  <a:tcPr marL="4649" marR="4649" marT="4649" marB="4649" anchor="ctr">
+                    <a:lnL>
+                      <a:noFill/>
+                    </a:lnL>
+                    <a:lnR>
+                      <a:noFill/>
+                    </a:lnR>
+                    <a:lnT>
+                      <a:noFill/>
+                    </a:lnT>
+                    <a:lnB>
+                      <a:noFill/>
+                    </a:lnB>
+                    <a:solidFill>
+                      <a:srgbClr val="FFFFFF"/>
+                    </a:solidFill>
+                  </a:tcPr>
+                </a:tc>
+                <a:tc>
+                  <a:txBody>
+                    <a:bodyPr/>
+                    <a:lstStyle/>
+                    <a:p>
+                      <a:r>
+                        <a:rPr lang="en-US" sz="1800">
+                          <a:effectLst/>
+                        </a:rPr>
+                        <a:t>9/18/2024</a:t>
+                      </a:r>
+                    </a:p>
+                  </a:txBody>
+                  <a:tcPr marL="4649" marR="4649" marT="4649" marB="4649" anchor="ctr">
+                    <a:lnL>
+                      <a:noFill/>
+                    </a:lnL>
+                    <a:lnR>
+                      <a:noFill/>
+                    </a:lnR>
+                    <a:lnT>
+                      <a:noFill/>
+                    </a:lnT>
+                    <a:lnB>
+                      <a:noFill/>
+                    </a:lnB>
+                    <a:solidFill>
+                      <a:srgbClr val="FFFFFF"/>
+                    </a:solidFill>
+                  </a:tcPr>
+                </a:tc>
+                <a:tc>
+                  <a:txBody>
+                    <a:bodyPr/>
+                    <a:lstStyle/>
+                    <a:p>
+                      <a:r>
+                        <a:rPr lang="en-US" sz="1800" dirty="0">
+                          <a:effectLst/>
+                        </a:rPr>
+                        <a:t>Image Restoration/Inverse filters</a:t>
+                      </a:r>
+                    </a:p>
+                  </a:txBody>
+                  <a:tcPr marL="4649" marR="4649" marT="4649" marB="4649" anchor="ctr">
+                    <a:lnL>
+                      <a:noFill/>
+                    </a:lnL>
+                    <a:lnR>
+                      <a:noFill/>
+                    </a:lnR>
+                    <a:lnT>
+                      <a:noFill/>
+                    </a:lnT>
+                    <a:lnB>
+                      <a:noFill/>
+                    </a:lnB>
+                    <a:solidFill>
+                      <a:srgbClr val="FFFFFF"/>
+                    </a:solidFill>
+                  </a:tcPr>
+                </a:tc>
+                <a:tc>
+                  <a:txBody>
+                    <a:bodyPr/>
+                    <a:lstStyle/>
+                    <a:p>
+                      <a:r>
+                        <a:rPr lang="en-US" sz="1800" dirty="0">
+                          <a:effectLst/>
+                        </a:rPr>
+                        <a:t>Group Project work</a:t>
+                      </a:r>
+                    </a:p>
+                  </a:txBody>
+                  <a:tcPr marL="4649" marR="4649" marT="4649" marB="4649" anchor="ctr">
+                    <a:lnL>
+                      <a:noFill/>
+                    </a:lnL>
+                    <a:lnR>
+                      <a:noFill/>
+                    </a:lnR>
+                    <a:lnT>
+                      <a:noFill/>
+                    </a:lnT>
+                    <a:lnB>
+                      <a:noFill/>
+                    </a:lnB>
+                    <a:solidFill>
+                      <a:srgbClr val="FFFFFF"/>
+                    </a:solidFill>
+                  </a:tcPr>
+                </a:tc>
+                <a:tc>
+                  <a:txBody>
+                    <a:bodyPr/>
+                    <a:lstStyle/>
+                    <a:p>
+                      <a:r>
+                        <a:rPr lang="en-US" sz="1800" dirty="0">
+                          <a:effectLst/>
+                        </a:rPr>
+                        <a:t>White paper on project</a:t>
+                      </a:r>
+                    </a:p>
+                  </a:txBody>
+                  <a:tcPr marL="4649" marR="4649" marT="4649" marB="4649" anchor="ctr">
+                    <a:lnL>
+                      <a:noFill/>
+                    </a:lnL>
+                    <a:lnR>
+                      <a:noFill/>
+                    </a:lnR>
+                    <a:lnT>
+                      <a:noFill/>
+                    </a:lnT>
+                    <a:lnB>
+                      <a:noFill/>
+                    </a:lnB>
+                    <a:solidFill>
+                      <a:srgbClr val="FFFFFF"/>
+                    </a:solidFill>
+                  </a:tcPr>
+                </a:tc>
+                <a:extLst>
+                  <a:ext uri="{0D108BD9-81ED-4DB2-BD59-A6C34878D82A}">
+                    <a16:rowId xmlns:a16="http://schemas.microsoft.com/office/drawing/2014/main" val="37833494"/>
+                  </a:ext>
+                </a:extLst>
+              </a:tr>
+              <a:tr h="191244">
+                <a:tc>
+                  <a:txBody>
+                    <a:bodyPr/>
+                    <a:lstStyle/>
+                    <a:p>
+                      <a:r>
+                        <a:rPr lang="en-US" sz="1800">
+                          <a:effectLst/>
+                        </a:rPr>
+                        <a:t>5</a:t>
+                      </a:r>
+                    </a:p>
+                  </a:txBody>
+                  <a:tcPr marL="4649" marR="4649" marT="4649" marB="4649" anchor="ctr">
+                    <a:lnL>
+                      <a:noFill/>
+                    </a:lnL>
+                    <a:lnR>
+                      <a:noFill/>
+                    </a:lnR>
+                    <a:lnT>
+                      <a:noFill/>
+                    </a:lnT>
+                    <a:lnB>
+                      <a:noFill/>
+                    </a:lnB>
+                    <a:solidFill>
+                      <a:srgbClr val="FFFFFF"/>
+                    </a:solidFill>
+                  </a:tcPr>
+                </a:tc>
+                <a:tc>
+                  <a:txBody>
+                    <a:bodyPr/>
+                    <a:lstStyle/>
+                    <a:p>
+                      <a:r>
+                        <a:rPr lang="en-US" sz="1800">
+                          <a:effectLst/>
+                        </a:rPr>
+                        <a:t>9/23/2024</a:t>
+                      </a:r>
+                    </a:p>
+                  </a:txBody>
+                  <a:tcPr marL="4649" marR="4649" marT="4649" marB="4649" anchor="ctr">
+                    <a:lnL>
+                      <a:noFill/>
+                    </a:lnL>
+                    <a:lnR>
+                      <a:noFill/>
+                    </a:lnR>
+                    <a:lnT>
+                      <a:noFill/>
+                    </a:lnT>
+                    <a:lnB>
+                      <a:noFill/>
+                    </a:lnB>
+                    <a:solidFill>
+                      <a:srgbClr val="FFFFFF"/>
+                    </a:solidFill>
+                  </a:tcPr>
+                </a:tc>
+                <a:tc>
+                  <a:txBody>
+                    <a:bodyPr/>
+                    <a:lstStyle/>
+                    <a:p>
+                      <a:r>
+                        <a:rPr lang="en-US" sz="1800" dirty="0">
+                          <a:effectLst/>
+                        </a:rPr>
+                        <a:t>Edge Detection</a:t>
+                      </a:r>
+                    </a:p>
+                  </a:txBody>
+                  <a:tcPr marL="4649" marR="4649" marT="4649" marB="4649" anchor="ctr">
+                    <a:lnL>
+                      <a:noFill/>
+                    </a:lnL>
+                    <a:lnR>
+                      <a:noFill/>
+                    </a:lnR>
+                    <a:lnT>
+                      <a:noFill/>
+                    </a:lnT>
+                    <a:lnB>
+                      <a:noFill/>
+                    </a:lnB>
+                    <a:solidFill>
+                      <a:srgbClr val="FFFFFF"/>
+                    </a:solidFill>
+                  </a:tcPr>
+                </a:tc>
+                <a:tc>
+                  <a:txBody>
+                    <a:bodyPr/>
+                    <a:lstStyle/>
+                    <a:p>
+                      <a:pPr marL="0" marR="0" lvl="0" indent="0" algn="l" defTabSz="914400" rtl="0" eaLnBrk="1" fontAlgn="auto" latinLnBrk="0" hangingPunct="1">
+                        <a:lnSpc>
+                          <a:spcPct val="100000"/>
+                        </a:lnSpc>
+                        <a:spcBef>
+                          <a:spcPts val="0"/>
+                        </a:spcBef>
+                        <a:spcAft>
+                          <a:spcPts val="0"/>
+                        </a:spcAft>
+                        <a:buClrTx/>
+                        <a:buSzTx/>
+                        <a:buFontTx/>
+                        <a:buNone/>
+                        <a:tabLst/>
+                        <a:defRPr/>
+                      </a:pPr>
+                      <a:r>
+                        <a:rPr lang="en-US" sz="1800" dirty="0">
+                          <a:effectLst/>
+                        </a:rPr>
+                        <a:t>Python problems (HW3)</a:t>
+                      </a:r>
+                    </a:p>
+                  </a:txBody>
+                  <a:tcPr marL="4649" marR="4649" marT="4649" marB="4649" anchor="ctr">
+                    <a:lnL>
+                      <a:noFill/>
+                    </a:lnL>
+                    <a:lnR>
+                      <a:noFill/>
+                    </a:lnR>
+                    <a:lnT>
+                      <a:noFill/>
+                    </a:lnT>
+                    <a:lnB>
+                      <a:noFill/>
+                    </a:lnB>
+                    <a:solidFill>
+                      <a:srgbClr val="FFFFFF"/>
+                    </a:solidFill>
+                  </a:tcPr>
+                </a:tc>
+                <a:tc>
+                  <a:txBody>
+                    <a:bodyPr/>
+                    <a:lstStyle/>
+                    <a:p>
+                      <a:pPr marL="0" marR="0" lvl="0" indent="0" algn="l" defTabSz="914400" rtl="0" eaLnBrk="1" fontAlgn="auto" latinLnBrk="0" hangingPunct="1">
+                        <a:lnSpc>
+                          <a:spcPct val="100000"/>
+                        </a:lnSpc>
+                        <a:spcBef>
+                          <a:spcPts val="0"/>
+                        </a:spcBef>
+                        <a:spcAft>
+                          <a:spcPts val="0"/>
+                        </a:spcAft>
+                        <a:buClrTx/>
+                        <a:buSzTx/>
+                        <a:buFontTx/>
+                        <a:buNone/>
+                        <a:tabLst/>
+                        <a:defRPr/>
+                      </a:pPr>
+                      <a:r>
+                        <a:rPr lang="en-US" sz="1800" dirty="0">
+                          <a:effectLst/>
+                        </a:rPr>
+                        <a:t>Due 9/30 </a:t>
+                      </a:r>
+                    </a:p>
+                  </a:txBody>
+                  <a:tcPr marL="4649" marR="4649" marT="4649" marB="4649" anchor="ctr">
+                    <a:lnL>
+                      <a:noFill/>
+                    </a:lnL>
+                    <a:lnR>
+                      <a:noFill/>
+                    </a:lnR>
+                    <a:lnT>
+                      <a:noFill/>
+                    </a:lnT>
+                    <a:lnB>
+                      <a:noFill/>
+                    </a:lnB>
+                    <a:solidFill>
+                      <a:srgbClr val="FFFFFF"/>
+                    </a:solidFill>
+                  </a:tcPr>
+                </a:tc>
+                <a:extLst>
+                  <a:ext uri="{0D108BD9-81ED-4DB2-BD59-A6C34878D82A}">
+                    <a16:rowId xmlns:a16="http://schemas.microsoft.com/office/drawing/2014/main" val="320480187"/>
+                  </a:ext>
+                </a:extLst>
+              </a:tr>
+              <a:tr h="191244">
+                <a:tc>
+                  <a:txBody>
+                    <a:bodyPr/>
+                    <a:lstStyle/>
+                    <a:p>
+                      <a:r>
+                        <a:rPr lang="en-US" sz="1800">
+                          <a:effectLst/>
+                        </a:rPr>
+                        <a:t> </a:t>
+                      </a:r>
+                    </a:p>
+                  </a:txBody>
+                  <a:tcPr marL="4649" marR="4649" marT="4649" marB="4649" anchor="ctr">
+                    <a:lnL>
+                      <a:noFill/>
+                    </a:lnL>
+                    <a:lnR>
+                      <a:noFill/>
+                    </a:lnR>
+                    <a:lnT>
+                      <a:noFill/>
+                    </a:lnT>
+                    <a:lnB>
+                      <a:noFill/>
+                    </a:lnB>
+                    <a:solidFill>
+                      <a:srgbClr val="FFFFFF"/>
+                    </a:solidFill>
+                  </a:tcPr>
+                </a:tc>
+                <a:tc>
+                  <a:txBody>
+                    <a:bodyPr/>
+                    <a:lstStyle/>
+                    <a:p>
+                      <a:r>
+                        <a:rPr lang="en-US" sz="1800">
+                          <a:effectLst/>
+                        </a:rPr>
+                        <a:t>9/25/2024</a:t>
+                      </a:r>
+                    </a:p>
+                  </a:txBody>
+                  <a:tcPr marL="4649" marR="4649" marT="4649" marB="4649" anchor="ctr">
+                    <a:lnL>
+                      <a:noFill/>
+                    </a:lnL>
+                    <a:lnR>
+                      <a:noFill/>
+                    </a:lnR>
+                    <a:lnT>
+                      <a:noFill/>
+                    </a:lnT>
+                    <a:lnB>
+                      <a:noFill/>
+                    </a:lnB>
+                    <a:solidFill>
+                      <a:srgbClr val="FFFFFF"/>
+                    </a:solidFill>
+                  </a:tcPr>
+                </a:tc>
+                <a:tc>
+                  <a:txBody>
+                    <a:bodyPr/>
+                    <a:lstStyle/>
+                    <a:p>
+                      <a:r>
+                        <a:rPr lang="en-US" sz="1800" dirty="0">
+                          <a:effectLst/>
+                        </a:rPr>
+                        <a:t>GMM Segmentation</a:t>
+                      </a:r>
+                    </a:p>
+                  </a:txBody>
+                  <a:tcPr marL="4649" marR="4649" marT="4649" marB="4649" anchor="ctr">
+                    <a:lnL>
+                      <a:noFill/>
+                    </a:lnL>
+                    <a:lnR>
+                      <a:noFill/>
+                    </a:lnR>
+                    <a:lnT>
+                      <a:noFill/>
+                    </a:lnT>
+                    <a:lnB>
+                      <a:noFill/>
+                    </a:lnB>
+                    <a:solidFill>
+                      <a:srgbClr val="FFFFFF"/>
+                    </a:solidFill>
+                  </a:tcPr>
+                </a:tc>
+                <a:tc>
+                  <a:txBody>
+                    <a:bodyPr/>
+                    <a:lstStyle/>
+                    <a:p>
+                      <a:r>
+                        <a:rPr lang="en-US" sz="1800" dirty="0">
+                          <a:effectLst/>
+                        </a:rPr>
+                        <a:t>Python problems (HW4)</a:t>
+                      </a:r>
+                    </a:p>
+                  </a:txBody>
+                  <a:tcPr marL="4649" marR="4649" marT="4649" marB="4649" anchor="ctr">
+                    <a:lnL>
+                      <a:noFill/>
+                    </a:lnL>
+                    <a:lnR>
+                      <a:noFill/>
+                    </a:lnR>
+                    <a:lnT>
+                      <a:noFill/>
+                    </a:lnT>
+                    <a:lnB>
+                      <a:noFill/>
+                    </a:lnB>
+                    <a:solidFill>
+                      <a:srgbClr val="FFFFFF"/>
+                    </a:solidFill>
+                  </a:tcPr>
+                </a:tc>
+                <a:tc>
+                  <a:txBody>
+                    <a:bodyPr/>
+                    <a:lstStyle/>
+                    <a:p>
+                      <a:r>
+                        <a:rPr lang="en-US" sz="1800" dirty="0">
+                          <a:effectLst/>
+                        </a:rPr>
+                        <a:t>Due 10/2</a:t>
+                      </a:r>
+                    </a:p>
+                  </a:txBody>
+                  <a:tcPr marL="4649" marR="4649" marT="4649" marB="4649" anchor="ctr">
+                    <a:lnL>
+                      <a:noFill/>
+                    </a:lnL>
+                    <a:lnR>
+                      <a:noFill/>
+                    </a:lnR>
+                    <a:lnT>
+                      <a:noFill/>
+                    </a:lnT>
+                    <a:lnB>
+                      <a:noFill/>
+                    </a:lnB>
+                    <a:solidFill>
+                      <a:srgbClr val="FFFFFF"/>
+                    </a:solidFill>
+                  </a:tcPr>
+                </a:tc>
+                <a:extLst>
+                  <a:ext uri="{0D108BD9-81ED-4DB2-BD59-A6C34878D82A}">
+                    <a16:rowId xmlns:a16="http://schemas.microsoft.com/office/drawing/2014/main" val="229511707"/>
+                  </a:ext>
+                </a:extLst>
+              </a:tr>
+              <a:tr h="191244">
+                <a:tc>
+                  <a:txBody>
+                    <a:bodyPr/>
+                    <a:lstStyle/>
+                    <a:p>
+                      <a:r>
+                        <a:rPr lang="en-US" sz="1800">
+                          <a:effectLst/>
+                        </a:rPr>
+                        <a:t>6</a:t>
+                      </a:r>
+                    </a:p>
+                  </a:txBody>
+                  <a:tcPr marL="4649" marR="4649" marT="4649" marB="4649" anchor="ctr">
+                    <a:lnL>
+                      <a:noFill/>
+                    </a:lnL>
+                    <a:lnR>
+                      <a:noFill/>
+                    </a:lnR>
+                    <a:lnT>
+                      <a:noFill/>
+                    </a:lnT>
+                    <a:lnB>
+                      <a:noFill/>
+                    </a:lnB>
+                    <a:solidFill>
+                      <a:srgbClr val="FFFFFF"/>
+                    </a:solidFill>
+                  </a:tcPr>
+                </a:tc>
+                <a:tc>
+                  <a:txBody>
+                    <a:bodyPr/>
+                    <a:lstStyle/>
+                    <a:p>
+                      <a:r>
+                        <a:rPr lang="en-US" sz="1800">
+                          <a:effectLst/>
+                        </a:rPr>
+                        <a:t>9/30/2024</a:t>
+                      </a:r>
+                    </a:p>
+                  </a:txBody>
+                  <a:tcPr marL="4649" marR="4649" marT="4649" marB="4649" anchor="ctr">
+                    <a:lnL>
+                      <a:noFill/>
+                    </a:lnL>
+                    <a:lnR>
+                      <a:noFill/>
+                    </a:lnR>
+                    <a:lnT>
+                      <a:noFill/>
+                    </a:lnT>
+                    <a:lnB>
+                      <a:noFill/>
+                    </a:lnB>
+                    <a:solidFill>
+                      <a:srgbClr val="FFFFFF"/>
+                    </a:solidFill>
+                  </a:tcPr>
+                </a:tc>
+                <a:tc>
+                  <a:txBody>
+                    <a:bodyPr/>
+                    <a:lstStyle/>
+                    <a:p>
+                      <a:r>
+                        <a:rPr lang="en-US" sz="1800" dirty="0">
+                          <a:effectLst/>
+                        </a:rPr>
+                        <a:t>Morphometric Segmentation</a:t>
+                      </a:r>
+                    </a:p>
+                  </a:txBody>
+                  <a:tcPr marL="4649" marR="4649" marT="4649" marB="4649" anchor="ctr">
+                    <a:lnL>
+                      <a:noFill/>
+                    </a:lnL>
+                    <a:lnR>
+                      <a:noFill/>
+                    </a:lnR>
+                    <a:lnT>
+                      <a:noFill/>
+                    </a:lnT>
+                    <a:lnB>
+                      <a:noFill/>
+                    </a:lnB>
+                    <a:solidFill>
+                      <a:srgbClr val="FFFFFF"/>
+                    </a:solidFill>
+                  </a:tcPr>
+                </a:tc>
+                <a:tc>
+                  <a:txBody>
+                    <a:bodyPr/>
+                    <a:lstStyle/>
+                    <a:p>
+                      <a:pPr marL="0" marR="0" lvl="0" indent="0" algn="l" defTabSz="914400" rtl="0" eaLnBrk="1" fontAlgn="auto" latinLnBrk="0" hangingPunct="1">
+                        <a:lnSpc>
+                          <a:spcPct val="100000"/>
+                        </a:lnSpc>
+                        <a:spcBef>
+                          <a:spcPts val="0"/>
+                        </a:spcBef>
+                        <a:spcAft>
+                          <a:spcPts val="0"/>
+                        </a:spcAft>
+                        <a:buClrTx/>
+                        <a:buSzTx/>
+                        <a:buFontTx/>
+                        <a:buNone/>
+                        <a:tabLst/>
+                        <a:defRPr/>
+                      </a:pPr>
+                      <a:r>
+                        <a:rPr lang="en-US" sz="1800" dirty="0">
+                          <a:effectLst/>
+                        </a:rPr>
+                        <a:t>Group Project work </a:t>
+                      </a:r>
+                    </a:p>
+                  </a:txBody>
+                  <a:tcPr marL="4649" marR="4649" marT="4649" marB="4649" anchor="ctr">
+                    <a:lnL>
+                      <a:noFill/>
+                    </a:lnL>
+                    <a:lnR>
+                      <a:noFill/>
+                    </a:lnR>
+                    <a:lnT>
+                      <a:noFill/>
+                    </a:lnT>
+                    <a:lnB>
+                      <a:noFill/>
+                    </a:lnB>
+                    <a:solidFill>
+                      <a:srgbClr val="FFFFFF"/>
+                    </a:solidFill>
+                  </a:tcPr>
+                </a:tc>
+                <a:tc>
+                  <a:txBody>
+                    <a:bodyPr/>
+                    <a:lstStyle/>
+                    <a:p>
+                      <a:endParaRPr lang="en-US" sz="1800" dirty="0">
+                        <a:effectLst/>
+                      </a:endParaRPr>
+                    </a:p>
+                  </a:txBody>
+                  <a:tcPr marL="4649" marR="4649" marT="4649" marB="4649" anchor="ctr">
+                    <a:lnL>
+                      <a:noFill/>
+                    </a:lnL>
+                    <a:lnR>
+                      <a:noFill/>
+                    </a:lnR>
+                    <a:lnT>
+                      <a:noFill/>
+                    </a:lnT>
+                    <a:lnB>
+                      <a:noFill/>
+                    </a:lnB>
+                    <a:solidFill>
+                      <a:srgbClr val="FFFFFF"/>
+                    </a:solidFill>
+                  </a:tcPr>
+                </a:tc>
+                <a:extLst>
+                  <a:ext uri="{0D108BD9-81ED-4DB2-BD59-A6C34878D82A}">
+                    <a16:rowId xmlns:a16="http://schemas.microsoft.com/office/drawing/2014/main" val="139372814"/>
+                  </a:ext>
+                </a:extLst>
+              </a:tr>
+              <a:tr h="191244">
+                <a:tc>
+                  <a:txBody>
+                    <a:bodyPr/>
+                    <a:lstStyle/>
+                    <a:p>
+                      <a:r>
+                        <a:rPr lang="en-US" sz="1800">
+                          <a:effectLst/>
+                        </a:rPr>
+                        <a:t> </a:t>
+                      </a:r>
+                    </a:p>
+                  </a:txBody>
+                  <a:tcPr marL="4649" marR="4649" marT="4649" marB="4649" anchor="ctr">
+                    <a:lnL>
+                      <a:noFill/>
+                    </a:lnL>
+                    <a:lnR>
+                      <a:noFill/>
+                    </a:lnR>
+                    <a:lnT>
+                      <a:noFill/>
+                    </a:lnT>
+                    <a:lnB>
+                      <a:noFill/>
+                    </a:lnB>
+                    <a:solidFill>
+                      <a:srgbClr val="FFFFFF"/>
+                    </a:solidFill>
+                  </a:tcPr>
+                </a:tc>
+                <a:tc>
+                  <a:txBody>
+                    <a:bodyPr/>
+                    <a:lstStyle/>
+                    <a:p>
+                      <a:r>
+                        <a:rPr lang="en-US" sz="1800">
+                          <a:effectLst/>
+                        </a:rPr>
+                        <a:t>10/2/2024</a:t>
+                      </a:r>
+                    </a:p>
+                  </a:txBody>
+                  <a:tcPr marL="4649" marR="4649" marT="4649" marB="4649" anchor="ctr">
+                    <a:lnL>
+                      <a:noFill/>
+                    </a:lnL>
+                    <a:lnR>
+                      <a:noFill/>
+                    </a:lnR>
+                    <a:lnT>
+                      <a:noFill/>
+                    </a:lnT>
+                    <a:lnB>
+                      <a:noFill/>
+                    </a:lnB>
+                    <a:solidFill>
+                      <a:srgbClr val="FFFFFF"/>
+                    </a:solidFill>
+                  </a:tcPr>
+                </a:tc>
+                <a:tc>
+                  <a:txBody>
+                    <a:bodyPr/>
+                    <a:lstStyle/>
+                    <a:p>
+                      <a:r>
+                        <a:rPr lang="en-US" sz="1800" dirty="0">
+                          <a:effectLst/>
+                        </a:rPr>
+                        <a:t>Image Feature Detection</a:t>
+                      </a:r>
+                    </a:p>
+                  </a:txBody>
+                  <a:tcPr marL="4649" marR="4649" marT="4649" marB="4649" anchor="ctr">
+                    <a:lnL>
+                      <a:noFill/>
+                    </a:lnL>
+                    <a:lnR>
+                      <a:noFill/>
+                    </a:lnR>
+                    <a:lnT>
+                      <a:noFill/>
+                    </a:lnT>
+                    <a:lnB>
+                      <a:noFill/>
+                    </a:lnB>
+                    <a:solidFill>
+                      <a:srgbClr val="FFFFFF"/>
+                    </a:solidFill>
+                  </a:tcPr>
+                </a:tc>
+                <a:tc>
+                  <a:txBody>
+                    <a:bodyPr/>
+                    <a:lstStyle/>
+                    <a:p>
+                      <a:r>
+                        <a:rPr lang="en-US" sz="1800" dirty="0">
+                          <a:effectLst/>
+                        </a:rPr>
+                        <a:t>Python problems  (HW5)</a:t>
+                      </a:r>
+                    </a:p>
+                  </a:txBody>
+                  <a:tcPr marL="4649" marR="4649" marT="4649" marB="4649" anchor="ctr">
+                    <a:lnL>
+                      <a:noFill/>
+                    </a:lnL>
+                    <a:lnR>
+                      <a:noFill/>
+                    </a:lnR>
+                    <a:lnT>
+                      <a:noFill/>
+                    </a:lnT>
+                    <a:lnB>
+                      <a:noFill/>
+                    </a:lnB>
+                    <a:solidFill>
+                      <a:srgbClr val="FFFFFF"/>
+                    </a:solidFill>
+                  </a:tcPr>
+                </a:tc>
+                <a:tc>
+                  <a:txBody>
+                    <a:bodyPr/>
+                    <a:lstStyle/>
+                    <a:p>
+                      <a:r>
+                        <a:rPr lang="en-US" sz="1800" dirty="0">
+                          <a:effectLst/>
+                        </a:rPr>
+                        <a:t>Due 10/9</a:t>
+                      </a:r>
+                    </a:p>
+                  </a:txBody>
+                  <a:tcPr marL="4649" marR="4649" marT="4649" marB="4649" anchor="ctr">
+                    <a:lnL>
+                      <a:noFill/>
+                    </a:lnL>
+                    <a:lnR>
+                      <a:noFill/>
+                    </a:lnR>
+                    <a:lnT>
+                      <a:noFill/>
+                    </a:lnT>
+                    <a:lnB>
+                      <a:noFill/>
+                    </a:lnB>
+                    <a:solidFill>
+                      <a:srgbClr val="FFFFFF"/>
+                    </a:solidFill>
+                  </a:tcPr>
+                </a:tc>
+                <a:extLst>
+                  <a:ext uri="{0D108BD9-81ED-4DB2-BD59-A6C34878D82A}">
+                    <a16:rowId xmlns:a16="http://schemas.microsoft.com/office/drawing/2014/main" val="268053897"/>
+                  </a:ext>
+                </a:extLst>
+              </a:tr>
+              <a:tr h="191244">
+                <a:tc>
+                  <a:txBody>
+                    <a:bodyPr/>
+                    <a:lstStyle/>
+                    <a:p>
+                      <a:r>
+                        <a:rPr lang="en-US" sz="1800">
+                          <a:effectLst/>
+                        </a:rPr>
+                        <a:t>7</a:t>
+                      </a:r>
+                    </a:p>
+                  </a:txBody>
+                  <a:tcPr marL="4649" marR="4649" marT="4649" marB="4649" anchor="ctr">
+                    <a:lnL>
+                      <a:noFill/>
+                    </a:lnL>
+                    <a:lnR>
+                      <a:noFill/>
+                    </a:lnR>
+                    <a:lnT>
+                      <a:noFill/>
+                    </a:lnT>
+                    <a:lnB>
+                      <a:noFill/>
+                    </a:lnB>
+                    <a:solidFill>
+                      <a:srgbClr val="FFFFFF"/>
+                    </a:solidFill>
+                  </a:tcPr>
+                </a:tc>
+                <a:tc>
+                  <a:txBody>
+                    <a:bodyPr/>
+                    <a:lstStyle/>
+                    <a:p>
+                      <a:r>
+                        <a:rPr lang="en-US" sz="1800">
+                          <a:effectLst/>
+                        </a:rPr>
+                        <a:t>10/7/2024</a:t>
+                      </a:r>
+                    </a:p>
+                  </a:txBody>
+                  <a:tcPr marL="4649" marR="4649" marT="4649" marB="4649" anchor="ctr">
+                    <a:lnL>
+                      <a:noFill/>
+                    </a:lnL>
+                    <a:lnR>
+                      <a:noFill/>
+                    </a:lnR>
+                    <a:lnT>
+                      <a:noFill/>
+                    </a:lnT>
+                    <a:lnB>
+                      <a:noFill/>
+                    </a:lnB>
+                    <a:solidFill>
+                      <a:srgbClr val="FFFFFF"/>
+                    </a:solidFill>
+                  </a:tcPr>
+                </a:tc>
+                <a:tc>
+                  <a:txBody>
+                    <a:bodyPr/>
+                    <a:lstStyle/>
+                    <a:p>
+                      <a:r>
+                        <a:rPr lang="en-US" sz="1800" dirty="0">
+                          <a:effectLst/>
+                        </a:rPr>
+                        <a:t>Registration &amp; </a:t>
+                      </a:r>
+                      <a:r>
+                        <a:rPr lang="en-US" sz="1800" dirty="0" err="1">
+                          <a:effectLst/>
+                        </a:rPr>
+                        <a:t>Homography</a:t>
+                      </a:r>
+                      <a:endParaRPr lang="en-US" sz="1800" dirty="0">
+                        <a:effectLst/>
+                      </a:endParaRPr>
+                    </a:p>
+                  </a:txBody>
+                  <a:tcPr marL="4649" marR="4649" marT="4649" marB="4649" anchor="ctr">
+                    <a:lnL>
+                      <a:noFill/>
+                    </a:lnL>
+                    <a:lnR>
+                      <a:noFill/>
+                    </a:lnR>
+                    <a:lnT>
+                      <a:noFill/>
+                    </a:lnT>
+                    <a:lnB>
+                      <a:noFill/>
+                    </a:lnB>
+                    <a:solidFill>
+                      <a:srgbClr val="FFFFFF"/>
+                    </a:solidFill>
+                  </a:tcPr>
+                </a:tc>
+                <a:tc>
+                  <a:txBody>
+                    <a:bodyPr/>
+                    <a:lstStyle/>
+                    <a:p>
+                      <a:pPr marL="0" marR="0" lvl="0" indent="0" algn="l" defTabSz="914400" rtl="0" eaLnBrk="1" fontAlgn="auto" latinLnBrk="0" hangingPunct="1">
+                        <a:lnSpc>
+                          <a:spcPct val="100000"/>
+                        </a:lnSpc>
+                        <a:spcBef>
+                          <a:spcPts val="0"/>
+                        </a:spcBef>
+                        <a:spcAft>
+                          <a:spcPts val="0"/>
+                        </a:spcAft>
+                        <a:buClrTx/>
+                        <a:buSzTx/>
+                        <a:buFontTx/>
+                        <a:buNone/>
+                        <a:tabLst/>
+                        <a:defRPr/>
+                      </a:pPr>
+                      <a:r>
+                        <a:rPr lang="en-US" sz="1800" dirty="0">
+                          <a:effectLst/>
+                        </a:rPr>
+                        <a:t>Python problems (HW6)</a:t>
+                      </a:r>
+                    </a:p>
+                  </a:txBody>
+                  <a:tcPr marL="4649" marR="4649" marT="4649" marB="4649" anchor="ctr">
+                    <a:lnL>
+                      <a:noFill/>
+                    </a:lnL>
+                    <a:lnR>
+                      <a:noFill/>
+                    </a:lnR>
+                    <a:lnT>
+                      <a:noFill/>
+                    </a:lnT>
+                    <a:lnB>
+                      <a:noFill/>
+                    </a:lnB>
+                    <a:solidFill>
+                      <a:srgbClr val="FFFFFF"/>
+                    </a:solidFill>
+                  </a:tcPr>
+                </a:tc>
+                <a:tc>
+                  <a:txBody>
+                    <a:bodyPr/>
+                    <a:lstStyle/>
+                    <a:p>
+                      <a:r>
+                        <a:rPr lang="en-US" sz="1800" dirty="0">
+                          <a:effectLst/>
+                        </a:rPr>
+                        <a:t>Due 10/16</a:t>
+                      </a:r>
+                    </a:p>
+                  </a:txBody>
+                  <a:tcPr marL="4649" marR="4649" marT="4649" marB="4649" anchor="ctr">
+                    <a:lnL>
+                      <a:noFill/>
+                    </a:lnL>
+                    <a:lnR>
+                      <a:noFill/>
+                    </a:lnR>
+                    <a:lnT>
+                      <a:noFill/>
+                    </a:lnT>
+                    <a:lnB>
+                      <a:noFill/>
+                    </a:lnB>
+                    <a:solidFill>
+                      <a:srgbClr val="FFFFFF"/>
+                    </a:solidFill>
+                  </a:tcPr>
+                </a:tc>
+                <a:extLst>
+                  <a:ext uri="{0D108BD9-81ED-4DB2-BD59-A6C34878D82A}">
+                    <a16:rowId xmlns:a16="http://schemas.microsoft.com/office/drawing/2014/main" val="1286783435"/>
+                  </a:ext>
+                </a:extLst>
+              </a:tr>
+              <a:tr h="191244">
+                <a:tc>
+                  <a:txBody>
+                    <a:bodyPr/>
+                    <a:lstStyle/>
+                    <a:p>
+                      <a:r>
+                        <a:rPr lang="en-US" sz="1800">
+                          <a:effectLst/>
+                        </a:rPr>
+                        <a:t> </a:t>
+                      </a:r>
+                    </a:p>
+                  </a:txBody>
+                  <a:tcPr marL="4649" marR="4649" marT="4649" marB="4649" anchor="ctr">
+                    <a:lnL>
+                      <a:noFill/>
+                    </a:lnL>
+                    <a:lnR>
+                      <a:noFill/>
+                    </a:lnR>
+                    <a:lnT>
+                      <a:noFill/>
+                    </a:lnT>
+                    <a:lnB>
+                      <a:noFill/>
+                    </a:lnB>
+                    <a:solidFill>
+                      <a:srgbClr val="FFFFFF"/>
+                    </a:solidFill>
+                  </a:tcPr>
+                </a:tc>
+                <a:tc>
+                  <a:txBody>
+                    <a:bodyPr/>
+                    <a:lstStyle/>
+                    <a:p>
+                      <a:r>
+                        <a:rPr lang="en-US" sz="1800">
+                          <a:effectLst/>
+                        </a:rPr>
+                        <a:t>10/9/2024</a:t>
+                      </a:r>
+                    </a:p>
+                  </a:txBody>
+                  <a:tcPr marL="4649" marR="4649" marT="4649" marB="4649" anchor="ctr">
+                    <a:lnL>
+                      <a:noFill/>
+                    </a:lnL>
+                    <a:lnR>
+                      <a:noFill/>
+                    </a:lnR>
+                    <a:lnT>
+                      <a:noFill/>
+                    </a:lnT>
+                    <a:lnB>
+                      <a:noFill/>
+                    </a:lnB>
+                    <a:solidFill>
+                      <a:srgbClr val="FFFFFF"/>
+                    </a:solidFill>
+                  </a:tcPr>
+                </a:tc>
+                <a:tc>
+                  <a:txBody>
+                    <a:bodyPr/>
+                    <a:lstStyle/>
+                    <a:p>
+                      <a:r>
+                        <a:rPr lang="en-US" sz="1800" dirty="0">
+                          <a:effectLst/>
+                        </a:rPr>
+                        <a:t>Computational Photography</a:t>
+                      </a:r>
+                    </a:p>
+                  </a:txBody>
+                  <a:tcPr marL="4649" marR="4649" marT="4649" marB="4649" anchor="ctr">
+                    <a:lnL>
+                      <a:noFill/>
+                    </a:lnL>
+                    <a:lnR>
+                      <a:noFill/>
+                    </a:lnR>
+                    <a:lnT>
+                      <a:noFill/>
+                    </a:lnT>
+                    <a:lnB>
+                      <a:noFill/>
+                    </a:lnB>
+                    <a:solidFill>
+                      <a:srgbClr val="FFFFFF"/>
+                    </a:solidFill>
+                  </a:tcPr>
+                </a:tc>
+                <a:tc>
+                  <a:txBody>
+                    <a:bodyPr/>
+                    <a:lstStyle/>
+                    <a:p>
+                      <a:r>
+                        <a:rPr lang="en-US" sz="1800" dirty="0">
+                          <a:effectLst/>
+                        </a:rPr>
+                        <a:t>Mid project assessment</a:t>
+                      </a:r>
+                    </a:p>
+                  </a:txBody>
+                  <a:tcPr marL="4649" marR="4649" marT="4649" marB="4649" anchor="ctr">
+                    <a:lnL>
+                      <a:noFill/>
+                    </a:lnL>
+                    <a:lnR>
+                      <a:noFill/>
+                    </a:lnR>
+                    <a:lnT>
+                      <a:noFill/>
+                    </a:lnT>
+                    <a:lnB>
+                      <a:noFill/>
+                    </a:lnB>
+                    <a:solidFill>
+                      <a:srgbClr val="FFFFFF"/>
+                    </a:solidFill>
+                  </a:tcPr>
+                </a:tc>
+                <a:tc>
+                  <a:txBody>
+                    <a:bodyPr/>
+                    <a:lstStyle/>
+                    <a:p>
+                      <a:r>
+                        <a:rPr lang="en-US" sz="1800" dirty="0">
+                          <a:effectLst/>
+                        </a:rPr>
+                        <a:t>Group ratings</a:t>
+                      </a:r>
+                    </a:p>
+                  </a:txBody>
+                  <a:tcPr marL="4649" marR="4649" marT="4649" marB="4649" anchor="ctr">
+                    <a:lnL>
+                      <a:noFill/>
+                    </a:lnL>
+                    <a:lnR>
+                      <a:noFill/>
+                    </a:lnR>
+                    <a:lnT>
+                      <a:noFill/>
+                    </a:lnT>
+                    <a:lnB>
+                      <a:noFill/>
+                    </a:lnB>
+                    <a:solidFill>
+                      <a:srgbClr val="FFFFFF"/>
+                    </a:solidFill>
+                  </a:tcPr>
+                </a:tc>
+                <a:extLst>
+                  <a:ext uri="{0D108BD9-81ED-4DB2-BD59-A6C34878D82A}">
+                    <a16:rowId xmlns:a16="http://schemas.microsoft.com/office/drawing/2014/main" val="688509921"/>
+                  </a:ext>
+                </a:extLst>
+              </a:tr>
+              <a:tr h="191244">
+                <a:tc>
+                  <a:txBody>
+                    <a:bodyPr/>
+                    <a:lstStyle/>
+                    <a:p>
+                      <a:r>
+                        <a:rPr lang="en-US" sz="1800">
+                          <a:effectLst/>
+                        </a:rPr>
+                        <a:t>8</a:t>
+                      </a:r>
+                    </a:p>
+                  </a:txBody>
+                  <a:tcPr marL="4649" marR="4649" marT="4649" marB="4649" anchor="ctr">
+                    <a:lnL>
+                      <a:noFill/>
+                    </a:lnL>
+                    <a:lnR>
+                      <a:noFill/>
+                    </a:lnR>
+                    <a:lnT>
+                      <a:noFill/>
+                    </a:lnT>
+                    <a:lnB>
+                      <a:noFill/>
+                    </a:lnB>
+                    <a:solidFill>
+                      <a:srgbClr val="FFFFFF"/>
+                    </a:solidFill>
+                  </a:tcPr>
+                </a:tc>
+                <a:tc>
+                  <a:txBody>
+                    <a:bodyPr/>
+                    <a:lstStyle/>
+                    <a:p>
+                      <a:r>
+                        <a:rPr lang="en-US" sz="1800">
+                          <a:effectLst/>
+                        </a:rPr>
+                        <a:t>10/14/2024</a:t>
+                      </a:r>
+                    </a:p>
+                  </a:txBody>
+                  <a:tcPr marL="4649" marR="4649" marT="4649" marB="4649" anchor="ctr">
+                    <a:lnL>
+                      <a:noFill/>
+                    </a:lnL>
+                    <a:lnR>
+                      <a:noFill/>
+                    </a:lnR>
+                    <a:lnT>
+                      <a:noFill/>
+                    </a:lnT>
+                    <a:lnB>
+                      <a:noFill/>
+                    </a:lnB>
+                    <a:solidFill>
+                      <a:srgbClr val="FFFFFF"/>
+                    </a:solidFill>
+                  </a:tcPr>
+                </a:tc>
+                <a:tc>
+                  <a:txBody>
+                    <a:bodyPr/>
+                    <a:lstStyle/>
+                    <a:p>
+                      <a:r>
+                        <a:rPr lang="en-US" sz="1800" dirty="0">
+                          <a:effectLst/>
+                        </a:rPr>
+                        <a:t>FALL Break [No Class]</a:t>
+                      </a:r>
+                    </a:p>
+                  </a:txBody>
+                  <a:tcPr marL="4649" marR="4649" marT="4649" marB="4649" anchor="ctr">
+                    <a:lnL>
+                      <a:noFill/>
+                    </a:lnL>
+                    <a:lnR>
+                      <a:noFill/>
+                    </a:lnR>
+                    <a:lnT>
+                      <a:noFill/>
+                    </a:lnT>
+                    <a:lnB>
+                      <a:noFill/>
+                    </a:lnB>
+                    <a:solidFill>
+                      <a:srgbClr val="FFFFFF"/>
+                    </a:solidFill>
+                  </a:tcPr>
+                </a:tc>
+                <a:tc>
+                  <a:txBody>
+                    <a:bodyPr/>
+                    <a:lstStyle/>
+                    <a:p>
+                      <a:r>
+                        <a:rPr lang="en-US" sz="1800" dirty="0">
+                          <a:effectLst/>
+                        </a:rPr>
+                        <a:t> </a:t>
+                      </a:r>
+                    </a:p>
+                  </a:txBody>
+                  <a:tcPr marL="4649" marR="4649" marT="4649" marB="4649" anchor="ctr">
+                    <a:lnL>
+                      <a:noFill/>
+                    </a:lnL>
+                    <a:lnR>
+                      <a:noFill/>
+                    </a:lnR>
+                    <a:lnT>
+                      <a:noFill/>
+                    </a:lnT>
+                    <a:lnB>
+                      <a:noFill/>
+                    </a:lnB>
+                    <a:solidFill>
+                      <a:srgbClr val="FFFFFF"/>
+                    </a:solidFill>
+                  </a:tcPr>
+                </a:tc>
+                <a:tc>
+                  <a:txBody>
+                    <a:bodyPr/>
+                    <a:lstStyle/>
+                    <a:p>
+                      <a:endParaRPr lang="en-US" sz="1800" dirty="0">
+                        <a:effectLst/>
+                      </a:endParaRPr>
+                    </a:p>
+                  </a:txBody>
+                  <a:tcPr marL="4649" marR="4649" marT="4649" marB="4649" anchor="ctr">
+                    <a:lnL>
+                      <a:noFill/>
+                    </a:lnL>
+                    <a:lnR>
+                      <a:noFill/>
+                    </a:lnR>
+                    <a:lnT>
+                      <a:noFill/>
+                    </a:lnT>
+                    <a:lnB>
+                      <a:noFill/>
+                    </a:lnB>
+                    <a:solidFill>
+                      <a:srgbClr val="FFFFFF"/>
+                    </a:solidFill>
+                  </a:tcPr>
+                </a:tc>
+                <a:extLst>
+                  <a:ext uri="{0D108BD9-81ED-4DB2-BD59-A6C34878D82A}">
+                    <a16:rowId xmlns:a16="http://schemas.microsoft.com/office/drawing/2014/main" val="784233871"/>
+                  </a:ext>
+                </a:extLst>
+              </a:tr>
+            </a:tbl>
+          </a:graphicData>
+        </a:graphic>
+      </p:graphicFrame>
+      <p:sp>
+        <p:nvSpPr>
+          <p:cNvPr id="7" name="Title 1">
+            <a:extLst>
+              <a:ext uri="{FF2B5EF4-FFF2-40B4-BE49-F238E27FC236}">
+                <a16:creationId xmlns:a16="http://schemas.microsoft.com/office/drawing/2014/main" id="{9B993CD8-C979-8658-6F14-F93089ACDCEE}"/>
+              </a:ext>
+            </a:extLst>
+          </p:cNvPr>
+          <p:cNvSpPr>
+            <a:spLocks noGrp="1"/>
+          </p:cNvSpPr>
+          <p:nvPr>
+            <p:ph type="title"/>
+          </p:nvPr>
+        </p:nvSpPr>
+        <p:spPr>
+          <a:xfrm>
+            <a:off x="838200" y="4616"/>
+            <a:ext cx="10515600" cy="1325563"/>
+          </a:xfrm>
+        </p:spPr>
+        <p:txBody>
+          <a:bodyPr/>
+          <a:lstStyle/>
+          <a:p>
+            <a:r>
+              <a:rPr lang="en-US" b="1" dirty="0"/>
+              <a:t>Syllabus</a:t>
+            </a:r>
+          </a:p>
+        </p:txBody>
+      </p:sp>
+      <p:sp>
+        <p:nvSpPr>
+          <p:cNvPr id="10" name="TextBox 9">
+            <a:extLst>
+              <a:ext uri="{FF2B5EF4-FFF2-40B4-BE49-F238E27FC236}">
+                <a16:creationId xmlns:a16="http://schemas.microsoft.com/office/drawing/2014/main" id="{D78011A4-2AF2-4DD2-BF08-511F97E015C9}"/>
+              </a:ext>
+            </a:extLst>
+          </p:cNvPr>
+          <p:cNvSpPr txBox="1"/>
+          <p:nvPr/>
+        </p:nvSpPr>
+        <p:spPr>
+          <a:xfrm>
+            <a:off x="8703733" y="138875"/>
+            <a:ext cx="3708401" cy="646331"/>
+          </a:xfrm>
+          <a:prstGeom prst="rect">
+            <a:avLst/>
+          </a:prstGeom>
+          <a:noFill/>
+        </p:spPr>
+        <p:txBody>
+          <a:bodyPr wrap="square">
+            <a:spAutoFit/>
+          </a:bodyPr>
+          <a:lstStyle/>
+          <a:p>
+            <a:r>
+              <a:rPr lang="en-US" sz="1800" dirty="0">
+                <a:solidFill>
+                  <a:srgbClr val="C00000"/>
+                </a:solidFill>
+                <a:effectLst/>
+              </a:rPr>
+              <a:t>* Lecture will be remote</a:t>
+            </a:r>
+          </a:p>
+          <a:p>
+            <a:r>
+              <a:rPr lang="en-US" dirty="0">
+                <a:solidFill>
+                  <a:srgbClr val="C00000"/>
+                </a:solidFill>
+              </a:rPr>
+              <a:t>** Lecture will be pre-recorded</a:t>
+            </a:r>
+          </a:p>
+        </p:txBody>
+      </p:sp>
+    </p:spTree>
+    <p:extLst>
+      <p:ext uri="{BB962C8B-B14F-4D97-AF65-F5344CB8AC3E}">
+        <p14:creationId xmlns:p14="http://schemas.microsoft.com/office/powerpoint/2010/main" val="369674791"/>
+      </p:ext>
+    </p:extLst>
+  </p:cSld>
+  <p:clrMapOvr>
+    <a:masterClrMapping/>
+  </p:clrMapOvr>
+</p:sld>
+</file>
+
+<file path=ppt/slides/slide3.xml><?xml version="1.0" encoding="utf-8"?>
 <p:sld xmlns:a="http://schemas.openxmlformats.org/drawingml/2006/main" xmlns:r="http://schemas.openxmlformats.org/officeDocument/2006/relationships" xmlns:p="http://schemas.openxmlformats.org/presentationml/2006/main">
   <p:cSld>
     <p:spTree>
@@ -10308,7 +13418,7 @@
 </p:sld>
 </file>
 
-<file path=ppt/slides/slide3.xml><?xml version="1.0" encoding="utf-8"?>
+<file path=ppt/slides/slide4.xml><?xml version="1.0" encoding="utf-8"?>
 <p:sld xmlns:a="http://schemas.openxmlformats.org/drawingml/2006/main" xmlns:r="http://schemas.openxmlformats.org/officeDocument/2006/relationships" xmlns:p="http://schemas.openxmlformats.org/presentationml/2006/main">
   <p:cSld>
     <p:spTree>
@@ -10504,89 +13614,6 @@
     <p:extLst>
       <p:ext uri="{BB962C8B-B14F-4D97-AF65-F5344CB8AC3E}">
         <p14:creationId xmlns:p14="http://schemas.microsoft.com/office/powerpoint/2010/main" val="2713536519"/>
-      </p:ext>
-    </p:extLst>
-  </p:cSld>
-  <p:clrMapOvr>
-    <a:masterClrMapping/>
-  </p:clrMapOvr>
-</p:sld>
-</file>
-
-<file path=ppt/slides/slide4.xml><?xml version="1.0" encoding="utf-8"?>
-<p:sld xmlns:a="http://schemas.openxmlformats.org/drawingml/2006/main" xmlns:r="http://schemas.openxmlformats.org/officeDocument/2006/relationships" xmlns:p="http://schemas.openxmlformats.org/presentationml/2006/main">
-  <p:cSld>
-    <p:spTree>
-      <p:nvGrpSpPr>
-        <p:cNvPr id="1" name=""/>
-        <p:cNvGrpSpPr/>
-        <p:nvPr/>
-      </p:nvGrpSpPr>
-      <p:grpSpPr>
-        <a:xfrm>
-          <a:off x="0" y="0"/>
-          <a:ext cx="0" cy="0"/>
-          <a:chOff x="0" y="0"/>
-          <a:chExt cx="0" cy="0"/>
-        </a:xfrm>
-      </p:grpSpPr>
-      <p:sp>
-        <p:nvSpPr>
-          <p:cNvPr id="2" name="Title 1">
-            <a:extLst>
-              <a:ext uri="{FF2B5EF4-FFF2-40B4-BE49-F238E27FC236}">
-                <a16:creationId xmlns:a16="http://schemas.microsoft.com/office/drawing/2014/main" id="{24120F1E-3E0A-C75A-B4EB-22E7096A349C}"/>
-              </a:ext>
-            </a:extLst>
-          </p:cNvPr>
-          <p:cNvSpPr>
-            <a:spLocks noGrp="1"/>
-          </p:cNvSpPr>
-          <p:nvPr>
-            <p:ph type="title"/>
-          </p:nvPr>
-        </p:nvSpPr>
-        <p:spPr/>
-        <p:txBody>
-          <a:bodyPr/>
-          <a:lstStyle/>
-          <a:p>
-            <a:r>
-              <a:rPr lang="en-US" dirty="0"/>
-              <a:t>HW1. Transforms/Filters/Color spaces</a:t>
-            </a:r>
-          </a:p>
-        </p:txBody>
-      </p:sp>
-      <p:sp>
-        <p:nvSpPr>
-          <p:cNvPr id="3" name="Content Placeholder 2">
-            <a:extLst>
-              <a:ext uri="{FF2B5EF4-FFF2-40B4-BE49-F238E27FC236}">
-                <a16:creationId xmlns:a16="http://schemas.microsoft.com/office/drawing/2014/main" id="{9F9D029D-2EB4-B7AE-F12C-E6C724512380}"/>
-              </a:ext>
-            </a:extLst>
-          </p:cNvPr>
-          <p:cNvSpPr>
-            <a:spLocks noGrp="1"/>
-          </p:cNvSpPr>
-          <p:nvPr>
-            <p:ph idx="1"/>
-          </p:nvPr>
-        </p:nvSpPr>
-        <p:spPr/>
-        <p:txBody>
-          <a:bodyPr/>
-          <a:lstStyle/>
-          <a:p>
-            <a:endParaRPr lang="en-US" dirty="0"/>
-          </a:p>
-        </p:txBody>
-      </p:sp>
-    </p:spTree>
-    <p:extLst>
-      <p:ext uri="{BB962C8B-B14F-4D97-AF65-F5344CB8AC3E}">
-        <p14:creationId xmlns:p14="http://schemas.microsoft.com/office/powerpoint/2010/main" val="606092454"/>
       </p:ext>
     </p:extLst>
   </p:cSld>
@@ -10636,7 +13663,7 @@
           <a:p>
             <a:r>
               <a:rPr lang="en-US" dirty="0"/>
-              <a:t>HW2. Filters/Image restoration</a:t>
+              <a:t>HW1. Transforms/Filters/Color spaces</a:t>
             </a:r>
           </a:p>
         </p:txBody>
@@ -10669,7 +13696,7 @@
     </p:spTree>
     <p:extLst>
       <p:ext uri="{BB962C8B-B14F-4D97-AF65-F5344CB8AC3E}">
-        <p14:creationId xmlns:p14="http://schemas.microsoft.com/office/powerpoint/2010/main" val="2740036088"/>
+        <p14:creationId xmlns:p14="http://schemas.microsoft.com/office/powerpoint/2010/main" val="606092454"/>
       </p:ext>
     </p:extLst>
   </p:cSld>
@@ -10719,7 +13746,7 @@
           <a:p>
             <a:r>
               <a:rPr lang="en-US" dirty="0"/>
-              <a:t>HW3. Edge detection and segmentation</a:t>
+              <a:t>HW2. Filters/Image restoration</a:t>
             </a:r>
           </a:p>
         </p:txBody>
@@ -10752,7 +13779,7 @@
     </p:spTree>
     <p:extLst>
       <p:ext uri="{BB962C8B-B14F-4D97-AF65-F5344CB8AC3E}">
-        <p14:creationId xmlns:p14="http://schemas.microsoft.com/office/powerpoint/2010/main" val="1754449796"/>
+        <p14:creationId xmlns:p14="http://schemas.microsoft.com/office/powerpoint/2010/main" val="2740036088"/>
       </p:ext>
     </p:extLst>
   </p:cSld>
@@ -10802,15 +13829,7 @@
           <a:p>
             <a:r>
               <a:rPr lang="en-US" dirty="0"/>
-              <a:t>HW4. </a:t>
-            </a:r>
-            <a:r>
-              <a:rPr lang="en-US" dirty="0" err="1"/>
-              <a:t>Morphalogical</a:t>
-            </a:r>
-            <a:r>
-              <a:rPr lang="en-US" dirty="0"/>
-              <a:t> segmentation</a:t>
+              <a:t>HW3. Edge detection and segmentation</a:t>
             </a:r>
           </a:p>
         </p:txBody>
@@ -10843,7 +13862,7 @@
     </p:spTree>
     <p:extLst>
       <p:ext uri="{BB962C8B-B14F-4D97-AF65-F5344CB8AC3E}">
-        <p14:creationId xmlns:p14="http://schemas.microsoft.com/office/powerpoint/2010/main" val="4143477606"/>
+        <p14:creationId xmlns:p14="http://schemas.microsoft.com/office/powerpoint/2010/main" val="1754449796"/>
       </p:ext>
     </p:extLst>
   </p:cSld>
@@ -10893,13 +13912,16 @@
           <a:p>
             <a:r>
               <a:rPr lang="en-US" dirty="0"/>
-              <a:t>HW5. Image registration/</a:t>
+              <a:t>HW4. </a:t>
             </a:r>
             <a:r>
               <a:rPr lang="en-US" dirty="0" err="1"/>
-              <a:t>homography</a:t>
+              <a:t>Morphalogical</a:t>
             </a:r>
-            <a:endParaRPr lang="en-US" dirty="0"/>
+            <a:r>
+              <a:rPr lang="en-US" dirty="0"/>
+              <a:t> segmentation</a:t>
+            </a:r>
           </a:p>
         </p:txBody>
       </p:sp>
@@ -10931,7 +13953,7 @@
     </p:spTree>
     <p:extLst>
       <p:ext uri="{BB962C8B-B14F-4D97-AF65-F5344CB8AC3E}">
-        <p14:creationId xmlns:p14="http://schemas.microsoft.com/office/powerpoint/2010/main" val="3012156812"/>
+        <p14:creationId xmlns:p14="http://schemas.microsoft.com/office/powerpoint/2010/main" val="4143477606"/>
       </p:ext>
     </p:extLst>
   </p:cSld>
@@ -10981,8 +14003,13 @@
           <a:p>
             <a:r>
               <a:rPr lang="en-US" dirty="0"/>
-              <a:t>HW6. HDR and Panoramas</a:t>
+              <a:t>HW5. Image registration/</a:t>
             </a:r>
+            <a:r>
+              <a:rPr lang="en-US" dirty="0" err="1"/>
+              <a:t>homography</a:t>
+            </a:r>
+            <a:endParaRPr lang="en-US" dirty="0"/>
           </a:p>
         </p:txBody>
       </p:sp>
@@ -11014,7 +14041,7 @@
     </p:spTree>
     <p:extLst>
       <p:ext uri="{BB962C8B-B14F-4D97-AF65-F5344CB8AC3E}">
-        <p14:creationId xmlns:p14="http://schemas.microsoft.com/office/powerpoint/2010/main" val="1527702628"/>
+        <p14:creationId xmlns:p14="http://schemas.microsoft.com/office/powerpoint/2010/main" val="3012156812"/>
       </p:ext>
     </p:extLst>
   </p:cSld>

</xml_diff>

<commit_message>
added PDF versions of all lectures and lecture 11
</commit_message>
<xml_diff>
--- a/ECE1390_Homework.pptx
+++ b/ECE1390_Homework.pptx
@@ -212,7 +212,7 @@
           <a:p>
             <a:fld id="{460182BA-D6B2-8C4C-A437-30BC8B3E8EFF}" type="datetimeFigureOut">
               <a:rPr lang="en-US" smtClean="0"/>
-              <a:t>9/11/24</a:t>
+              <a:t>10/3/24</a:t>
             </a:fld>
             <a:endParaRPr lang="en-US"/>
           </a:p>
@@ -902,7 +902,7 @@
           <a:p>
             <a:fld id="{13E9B49C-C8FD-4344-8CD3-ED4C91409D68}" type="datetimeFigureOut">
               <a:rPr lang="en-US" smtClean="0"/>
-              <a:t>9/11/24</a:t>
+              <a:t>10/3/24</a:t>
             </a:fld>
             <a:endParaRPr lang="en-US"/>
           </a:p>
@@ -1100,7 +1100,7 @@
           <a:p>
             <a:fld id="{13E9B49C-C8FD-4344-8CD3-ED4C91409D68}" type="datetimeFigureOut">
               <a:rPr lang="en-US" smtClean="0"/>
-              <a:t>9/11/24</a:t>
+              <a:t>10/3/24</a:t>
             </a:fld>
             <a:endParaRPr lang="en-US"/>
           </a:p>
@@ -1308,7 +1308,7 @@
           <a:p>
             <a:fld id="{13E9B49C-C8FD-4344-8CD3-ED4C91409D68}" type="datetimeFigureOut">
               <a:rPr lang="en-US" smtClean="0"/>
-              <a:t>9/11/24</a:t>
+              <a:t>10/3/24</a:t>
             </a:fld>
             <a:endParaRPr lang="en-US"/>
           </a:p>
@@ -1506,7 +1506,7 @@
           <a:p>
             <a:fld id="{13E9B49C-C8FD-4344-8CD3-ED4C91409D68}" type="datetimeFigureOut">
               <a:rPr lang="en-US" smtClean="0"/>
-              <a:t>9/11/24</a:t>
+              <a:t>10/3/24</a:t>
             </a:fld>
             <a:endParaRPr lang="en-US"/>
           </a:p>
@@ -1781,7 +1781,7 @@
           <a:p>
             <a:fld id="{13E9B49C-C8FD-4344-8CD3-ED4C91409D68}" type="datetimeFigureOut">
               <a:rPr lang="en-US" smtClean="0"/>
-              <a:t>9/11/24</a:t>
+              <a:t>10/3/24</a:t>
             </a:fld>
             <a:endParaRPr lang="en-US"/>
           </a:p>
@@ -2046,7 +2046,7 @@
           <a:p>
             <a:fld id="{13E9B49C-C8FD-4344-8CD3-ED4C91409D68}" type="datetimeFigureOut">
               <a:rPr lang="en-US" smtClean="0"/>
-              <a:t>9/11/24</a:t>
+              <a:t>10/3/24</a:t>
             </a:fld>
             <a:endParaRPr lang="en-US"/>
           </a:p>
@@ -2458,7 +2458,7 @@
           <a:p>
             <a:fld id="{13E9B49C-C8FD-4344-8CD3-ED4C91409D68}" type="datetimeFigureOut">
               <a:rPr lang="en-US" smtClean="0"/>
-              <a:t>9/11/24</a:t>
+              <a:t>10/3/24</a:t>
             </a:fld>
             <a:endParaRPr lang="en-US"/>
           </a:p>
@@ -2599,7 +2599,7 @@
           <a:p>
             <a:fld id="{13E9B49C-C8FD-4344-8CD3-ED4C91409D68}" type="datetimeFigureOut">
               <a:rPr lang="en-US" smtClean="0"/>
-              <a:t>9/11/24</a:t>
+              <a:t>10/3/24</a:t>
             </a:fld>
             <a:endParaRPr lang="en-US"/>
           </a:p>
@@ -2712,7 +2712,7 @@
           <a:p>
             <a:fld id="{13E9B49C-C8FD-4344-8CD3-ED4C91409D68}" type="datetimeFigureOut">
               <a:rPr lang="en-US" smtClean="0"/>
-              <a:t>9/11/24</a:t>
+              <a:t>10/3/24</a:t>
             </a:fld>
             <a:endParaRPr lang="en-US"/>
           </a:p>
@@ -3023,7 +3023,7 @@
           <a:p>
             <a:fld id="{13E9B49C-C8FD-4344-8CD3-ED4C91409D68}" type="datetimeFigureOut">
               <a:rPr lang="en-US" smtClean="0"/>
-              <a:t>9/11/24</a:t>
+              <a:t>10/3/24</a:t>
             </a:fld>
             <a:endParaRPr lang="en-US"/>
           </a:p>
@@ -3311,7 +3311,7 @@
           <a:p>
             <a:fld id="{13E9B49C-C8FD-4344-8CD3-ED4C91409D68}" type="datetimeFigureOut">
               <a:rPr lang="en-US" smtClean="0"/>
-              <a:t>9/11/24</a:t>
+              <a:t>10/3/24</a:t>
             </a:fld>
             <a:endParaRPr lang="en-US"/>
           </a:p>
@@ -3552,7 +3552,7 @@
           <a:p>
             <a:fld id="{13E9B49C-C8FD-4344-8CD3-ED4C91409D68}" type="datetimeFigureOut">
               <a:rPr lang="en-US" smtClean="0"/>
-              <a:t>9/11/24</a:t>
+              <a:t>10/3/24</a:t>
             </a:fld>
             <a:endParaRPr lang="en-US"/>
           </a:p>
@@ -6489,7 +6489,7 @@
                     <a:lstStyle/>
                     <a:p>
                       <a:r>
-                        <a:rPr lang="en-US" sz="1800">
+                        <a:rPr lang="en-US" sz="1800" dirty="0">
                           <a:effectLst/>
                         </a:rPr>
                         <a:t>Inpainting (Missing data)</a:t>
@@ -7460,7 +7460,7 @@
           <p:nvPr>
             <p:extLst>
               <p:ext uri="{D42A27DB-BD31-4B8C-83A1-F6EECF244321}">
-                <p14:modId xmlns:p14="http://schemas.microsoft.com/office/powerpoint/2010/main" val="2061333659"/>
+                <p14:modId xmlns:p14="http://schemas.microsoft.com/office/powerpoint/2010/main" val="2909657002"/>
               </p:ext>
             </p:extLst>
           </p:nvPr>
@@ -9374,7 +9374,7 @@
                         <a:rPr lang="en-US" sz="1800" dirty="0">
                           <a:effectLst/>
                         </a:rPr>
-                        <a:t>Due 10/2</a:t>
+                        <a:t>Due 10/9</a:t>
                       </a:r>
                     </a:p>
                   </a:txBody>
@@ -9677,43 +9677,37 @@
                     <a:bodyPr/>
                     <a:lstStyle/>
                     <a:p>
-                      <a:r>
-                        <a:rPr lang="en-US" sz="1800" dirty="0">
-                          <a:effectLst/>
-                        </a:rPr>
-                        <a:t>Python problems  (HW5)</a:t>
-                      </a:r>
-                    </a:p>
-                  </a:txBody>
-                  <a:tcPr marL="4649" marR="4649" marT="4649" marB="4649" anchor="ctr">
-                    <a:lnL>
-                      <a:noFill/>
-                    </a:lnL>
-                    <a:lnR>
-                      <a:noFill/>
-                    </a:lnR>
-                    <a:lnT>
-                      <a:noFill/>
-                    </a:lnT>
-                    <a:lnB>
-                      <a:noFill/>
-                    </a:lnB>
-                    <a:solidFill>
-                      <a:srgbClr val="FFFFFF"/>
-                    </a:solidFill>
-                  </a:tcPr>
-                </a:tc>
-                <a:tc>
-                  <a:txBody>
-                    <a:bodyPr/>
-                    <a:lstStyle/>
-                    <a:p>
-                      <a:r>
-                        <a:rPr lang="en-US" sz="1800" dirty="0">
-                          <a:effectLst/>
-                        </a:rPr>
-                        <a:t>Due 10/9</a:t>
-                      </a:r>
+                      <a:endParaRPr lang="en-US" sz="1800" dirty="0">
+                        <a:effectLst/>
+                      </a:endParaRPr>
+                    </a:p>
+                  </a:txBody>
+                  <a:tcPr marL="4649" marR="4649" marT="4649" marB="4649" anchor="ctr">
+                    <a:lnL>
+                      <a:noFill/>
+                    </a:lnL>
+                    <a:lnR>
+                      <a:noFill/>
+                    </a:lnR>
+                    <a:lnT>
+                      <a:noFill/>
+                    </a:lnT>
+                    <a:lnB>
+                      <a:noFill/>
+                    </a:lnB>
+                    <a:solidFill>
+                      <a:srgbClr val="FFFFFF"/>
+                    </a:solidFill>
+                  </a:tcPr>
+                </a:tc>
+                <a:tc>
+                  <a:txBody>
+                    <a:bodyPr/>
+                    <a:lstStyle/>
+                    <a:p>
+                      <a:endParaRPr lang="en-US" sz="1800" dirty="0">
+                        <a:effectLst/>
+                      </a:endParaRPr>
                     </a:p>
                   </a:txBody>
                   <a:tcPr marL="4649" marR="4649" marT="4649" marB="4649" anchor="ctr">
@@ -9869,7 +9863,7 @@
                         <a:rPr lang="en-US" sz="1800" dirty="0">
                           <a:effectLst/>
                         </a:rPr>
-                        <a:t>Python problems (HW6)</a:t>
+                        <a:t>Python problems (HW5)</a:t>
                       </a:r>
                     </a:p>
                   </a:txBody>
@@ -10413,7 +10407,7 @@
           <p:nvPr>
             <p:extLst>
               <p:ext uri="{D42A27DB-BD31-4B8C-83A1-F6EECF244321}">
-                <p14:modId xmlns:p14="http://schemas.microsoft.com/office/powerpoint/2010/main" val="3722345538"/>
+                <p14:modId xmlns:p14="http://schemas.microsoft.com/office/powerpoint/2010/main" val="3635971484"/>
               </p:ext>
             </p:extLst>
           </p:nvPr>
@@ -10896,7 +10890,7 @@
                         <a:rPr lang="en-US" sz="1800" dirty="0">
                           <a:effectLst/>
                         </a:rPr>
-                        <a:t>Python problems (HW7)</a:t>
+                        <a:t>Python problems (HW6)</a:t>
                       </a:r>
                     </a:p>
                   </a:txBody>
@@ -11217,7 +11211,7 @@
                         <a:rPr lang="en-US" sz="1800" dirty="0">
                           <a:effectLst/>
                         </a:rPr>
-                        <a:t>Python problems (HW8)</a:t>
+                        <a:t>Python problems (HW7)</a:t>
                       </a:r>
                     </a:p>
                   </a:txBody>
@@ -11379,7 +11373,7 @@
                         <a:rPr lang="en-US" sz="1800" dirty="0">
                           <a:effectLst/>
                         </a:rPr>
-                        <a:t>Python problems (HW9)</a:t>
+                        <a:t>Python problems (HW8)</a:t>
                       </a:r>
                     </a:p>
                   </a:txBody>
@@ -11666,10 +11660,10 @@
                     <a:lstStyle/>
                     <a:p>
                       <a:r>
-                        <a:rPr lang="en-US" sz="1800">
-                          <a:effectLst/>
-                        </a:rPr>
-                        <a:t>Harris Corners and Blobs</a:t>
+                        <a:rPr lang="en-US" sz="1800" dirty="0">
+                          <a:effectLst/>
+                        </a:rPr>
+                        <a:t>HOG and Custom Detectors</a:t>
                       </a:r>
                     </a:p>
                   </a:txBody>
@@ -11828,7 +11822,7 @@
                         <a:rPr lang="en-US" sz="1800" dirty="0">
                           <a:effectLst/>
                         </a:rPr>
-                        <a:t>HOG and Custom Detectors</a:t>
+                        <a:t>Object Tracking</a:t>
                       </a:r>
                     </a:p>
                   </a:txBody>
@@ -11859,7 +11853,7 @@
                         <a:rPr lang="en-US" sz="1800" dirty="0">
                           <a:effectLst/>
                         </a:rPr>
-                        <a:t>Python problems (HW10)</a:t>
+                        <a:t>Python problems (HW9)</a:t>
                       </a:r>
                     </a:p>
                   </a:txBody>
@@ -11990,7 +11984,7 @@
                         <a:rPr lang="en-US" sz="1800" dirty="0">
                           <a:effectLst/>
                         </a:rPr>
-                        <a:t>Object Tracking</a:t>
+                        <a:t>OCR Text Detection</a:t>
                       </a:r>
                     </a:p>
                   </a:txBody>
@@ -12149,7 +12143,7 @@
                         <a:rPr lang="en-US" sz="1800" dirty="0">
                           <a:effectLst/>
                         </a:rPr>
-                        <a:t>OCR Text Detection</a:t>
+                        <a:t>OpenCV DNN</a:t>
                       </a:r>
                     </a:p>
                   </a:txBody>
@@ -12180,7 +12174,7 @@
                         <a:rPr lang="en-US" sz="1800" dirty="0">
                           <a:effectLst/>
                         </a:rPr>
-                        <a:t>Python problems (HW11)</a:t>
+                        <a:t>Python problems (HW10)</a:t>
                       </a:r>
                     </a:p>
                   </a:txBody>
@@ -12311,7 +12305,7 @@
                         <a:rPr lang="en-US" sz="1800" dirty="0">
                           <a:effectLst/>
                         </a:rPr>
-                        <a:t>OpenCV DNN</a:t>
+                        <a:t>Super Resolution</a:t>
                       </a:r>
                     </a:p>
                   </a:txBody>
@@ -12359,7 +12353,7 @@
                         <a:rPr lang="en-US" sz="1800" dirty="0">
                           <a:effectLst/>
                         </a:rPr>
-                        <a:t>Python problems (HW12)</a:t>
+                        <a:t>Python problems (HW11)</a:t>
                       </a:r>
                     </a:p>
                   </a:txBody>
@@ -12486,11 +12480,34 @@
                     <a:bodyPr/>
                     <a:lstStyle/>
                     <a:p>
+                      <a:pPr marL="0" marR="0" lvl="0" indent="0" algn="l" defTabSz="914400" rtl="0" eaLnBrk="1" fontAlgn="auto" latinLnBrk="0" hangingPunct="1">
+                        <a:lnSpc>
+                          <a:spcPct val="100000"/>
+                        </a:lnSpc>
+                        <a:spcBef>
+                          <a:spcPts val="0"/>
+                        </a:spcBef>
+                        <a:spcAft>
+                          <a:spcPts val="0"/>
+                        </a:spcAft>
+                        <a:buClrTx/>
+                        <a:buSzTx/>
+                        <a:buFontTx/>
+                        <a:buNone/>
+                        <a:tabLst/>
+                        <a:defRPr/>
+                      </a:pPr>
+                      <a:r>
+                        <a:rPr lang="en-US" sz="1800" dirty="0" err="1">
+                          <a:effectLst/>
+                        </a:rPr>
+                        <a:t>MediaPipe</a:t>
+                      </a:r>
                       <a:r>
                         <a:rPr lang="en-US" sz="1800" dirty="0">
                           <a:effectLst/>
                         </a:rPr>
-                        <a:t>Super Resolution</a:t>
+                        <a:t>/SLAM</a:t>
                       </a:r>
                     </a:p>
                   </a:txBody>
@@ -12974,37 +12991,6 @@
                     <a:bodyPr/>
                     <a:lstStyle/>
                     <a:p>
-                      <a:r>
-                        <a:rPr lang="en-US" sz="1800" dirty="0">
-                          <a:effectLst/>
-                        </a:rPr>
-                        <a:t>SLAM</a:t>
-                      </a:r>
-                    </a:p>
-                  </a:txBody>
-                  <a:tcPr marL="4649" marR="4649" marT="4649" marB="4649" anchor="ctr">
-                    <a:lnL>
-                      <a:noFill/>
-                    </a:lnL>
-                    <a:lnR>
-                      <a:noFill/>
-                    </a:lnR>
-                    <a:lnT>
-                      <a:noFill/>
-                    </a:lnT>
-                    <a:lnB>
-                      <a:noFill/>
-                    </a:lnB>
-                    <a:solidFill>
-                      <a:srgbClr val="FFFFFF"/>
-                    </a:solidFill>
-                  </a:tcPr>
-                </a:tc>
-                <a:tc>
-                  <a:txBody>
-                    <a:bodyPr/>
-                    <a:lstStyle/>
-                    <a:p>
                       <a:pPr marL="0" marR="0" lvl="0" indent="0" algn="l" defTabSz="914400" rtl="0" eaLnBrk="1" fontAlgn="auto" latinLnBrk="0" hangingPunct="1">
                         <a:lnSpc>
                           <a:spcPct val="100000"/>
@@ -13053,6 +13039,54 @@
                     <a:bodyPr/>
                     <a:lstStyle/>
                     <a:p>
+                      <a:pPr marL="0" marR="0" lvl="0" indent="0" algn="l" defTabSz="914400" rtl="0" eaLnBrk="1" fontAlgn="auto" latinLnBrk="0" hangingPunct="1">
+                        <a:lnSpc>
+                          <a:spcPct val="100000"/>
+                        </a:lnSpc>
+                        <a:spcBef>
+                          <a:spcPts val="0"/>
+                        </a:spcBef>
+                        <a:spcAft>
+                          <a:spcPts val="0"/>
+                        </a:spcAft>
+                        <a:buClrTx/>
+                        <a:buSzTx/>
+                        <a:buFontTx/>
+                        <a:buNone/>
+                        <a:tabLst/>
+                        <a:defRPr/>
+                      </a:pPr>
+                      <a:r>
+                        <a:rPr lang="en-US" sz="1800" dirty="0">
+                          <a:effectLst/>
+                        </a:rPr>
+                        <a:t>Group Project work</a:t>
+                      </a:r>
+                    </a:p>
+                  </a:txBody>
+                  <a:tcPr marL="4649" marR="4649" marT="4649" marB="4649" anchor="ctr">
+                    <a:lnL>
+                      <a:noFill/>
+                    </a:lnL>
+                    <a:lnR>
+                      <a:noFill/>
+                    </a:lnR>
+                    <a:lnT>
+                      <a:noFill/>
+                    </a:lnT>
+                    <a:lnB>
+                      <a:noFill/>
+                    </a:lnB>
+                    <a:solidFill>
+                      <a:srgbClr val="FFFFFF"/>
+                    </a:solidFill>
+                  </a:tcPr>
+                </a:tc>
+                <a:tc>
+                  <a:txBody>
+                    <a:bodyPr/>
+                    <a:lstStyle/>
+                    <a:p>
                       <a:endParaRPr lang="en-US" sz="1800" dirty="0">
                         <a:effectLst/>
                       </a:endParaRPr>
@@ -13150,15 +13184,29 @@
                     <a:bodyPr/>
                     <a:lstStyle/>
                     <a:p>
-                      <a:r>
-                        <a:rPr lang="en-US" sz="1800" dirty="0" err="1">
-                          <a:effectLst/>
-                        </a:rPr>
-                        <a:t>MediaPipe</a:t>
-                      </a:r>
-                      <a:endParaRPr lang="en-US" sz="1800" dirty="0">
-                        <a:effectLst/>
-                      </a:endParaRPr>
+                      <a:pPr marL="0" marR="0" lvl="0" indent="0" algn="l" defTabSz="914400" rtl="0" eaLnBrk="1" fontAlgn="auto" latinLnBrk="0" hangingPunct="1">
+                        <a:lnSpc>
+                          <a:spcPct val="100000"/>
+                        </a:lnSpc>
+                        <a:spcBef>
+                          <a:spcPts val="0"/>
+                        </a:spcBef>
+                        <a:spcAft>
+                          <a:spcPts val="0"/>
+                        </a:spcAft>
+                        <a:buClrTx/>
+                        <a:buSzTx/>
+                        <a:buFontTx/>
+                        <a:buNone/>
+                        <a:tabLst/>
+                        <a:defRPr/>
+                      </a:pPr>
+                      <a:r>
+                        <a:rPr lang="en-US" sz="1800" dirty="0">
+                          <a:effectLst/>
+                        </a:rPr>
+                        <a:t>Group Project work</a:t>
+                      </a:r>
                     </a:p>
                   </a:txBody>
                   <a:tcPr marL="4649" marR="4649" marT="4649" marB="4649" anchor="ctr">

</xml_diff>